<commit_message>
feat(slides): upgrade WS1-WS5 14-slide 3-Act decks with slide-design v2.0.0 opaque edge pills & zero ellipsis and patch all Google Drive IDs in-place
</commit_message>
<xml_diff>
--- a/slides/ws1-reference-architecture-editable-slides.pptx
+++ b/slides/ws1-reference-architecture-editable-slides.pptx
@@ -6423,14 +6423,16 @@
           <a:ln/>
         </p:spPr>
         <p:txBody>
-          <a:bodyPr wrap="square" rtlCol="0" anchor="ctr"/>
+          <a:bodyPr wrap="square" rtlCol="0" anchor="ctr">
+            <a:normAutofit/>
+          </a:bodyPr>
           <a:lstStyle/>
           <a:p>
             <a:pPr indent="0" marL="0">
               <a:buNone/>
             </a:pPr>
             <a:r>
-              <a:rPr lang="en-US" sz="820" b="1" dirty="0">
+              <a:rPr lang="en-US" sz="760" b="1" dirty="0">
                 <a:solidFill>
                   <a:srgbClr val="3C4043"/>
                 </a:solidFill>
@@ -6438,9 +6440,9 @@
                 <a:ea typeface="Google Sans" pitchFamily="34" charset="-122"/>
                 <a:cs typeface="Google Sans" pitchFamily="34" charset="-120"/>
               </a:rPr>
-              <a:t>1. GAP-01 (Hop 2) • Agent Engine Regi…</a:t>
-            </a:r>
-            <a:endParaRPr lang="en-US" sz="820" dirty="0"/>
+              <a:t>1. GAP-01 (Hop 2) • Agent Engine Registry</a:t>
+            </a:r>
+            <a:endParaRPr lang="en-US" sz="760" dirty="0"/>
           </a:p>
         </p:txBody>
       </p:sp>
@@ -6479,7 +6481,7 @@
                 <a:ea typeface="Roboto" pitchFamily="34" charset="-122"/>
                 <a:cs typeface="Roboto" pitchFamily="34" charset="-120"/>
               </a:rPr>
-              <a:t>WS2 Test 2 PASS (HTTP 403 on cross-tenant Agent Alpha discovery) • Target GA: Q4 2026 (Shared Agent Engine Registry lacks native per…</a:t>
+              <a:t>WS2 Test 2 PASS (HTTP 403 on cross-tenant Agent Alpha discovery) • Target GA: Q4 2026</a:t>
             </a:r>
             <a:endParaRPr lang="en-US" sz="740" dirty="0"/>
           </a:p>
@@ -6550,7 +6552,9 @@
           <a:ln/>
         </p:spPr>
         <p:txBody>
-          <a:bodyPr wrap="square" rtlCol="0" anchor="ctr"/>
+          <a:bodyPr wrap="square" rtlCol="0" anchor="ctr">
+            <a:normAutofit/>
+          </a:bodyPr>
           <a:lstStyle/>
           <a:p>
             <a:pPr indent="0" marL="0">
@@ -6606,7 +6610,7 @@
                 <a:ea typeface="Roboto" pitchFamily="34" charset="-122"/>
                 <a:cs typeface="Roboto" pitchFamily="34" charset="-120"/>
               </a:rPr>
-              <a:t>WS3 Tests 4A/4B/6 PASS (HTTP 423 Locked &lt;60s on key disable) • Target GA: Q4 2026 (Pooled Vertex AI Memory Bank supports project-lev…</a:t>
+              <a:t>WS3 Tests 4A/4B/6 PASS (HTTP 423 Locked &lt;60s on key disable) • Target GA: Q4 2026</a:t>
             </a:r>
             <a:endParaRPr lang="en-US" sz="740" dirty="0"/>
           </a:p>
@@ -6677,14 +6681,16 @@
           <a:ln/>
         </p:spPr>
         <p:txBody>
-          <a:bodyPr wrap="square" rtlCol="0" anchor="ctr"/>
+          <a:bodyPr wrap="square" rtlCol="0" anchor="ctr">
+            <a:normAutofit/>
+          </a:bodyPr>
           <a:lstStyle/>
           <a:p>
             <a:pPr indent="0" marL="0">
               <a:buNone/>
             </a:pPr>
             <a:r>
-              <a:rPr lang="en-US" sz="820" b="1" dirty="0">
+              <a:rPr lang="en-US" sz="760" b="1" dirty="0">
                 <a:solidFill>
                   <a:srgbClr val="3C4043"/>
                 </a:solidFill>
@@ -6692,9 +6698,9 @@
                 <a:ea typeface="Google Sans" pitchFamily="34" charset="-122"/>
                 <a:cs typeface="Google Sans" pitchFamily="34" charset="-120"/>
               </a:rPr>
-              <a:t>3. GAP-03 (Hop 3) • Per-Tenant Rate Q…</a:t>
-            </a:r>
-            <a:endParaRPr lang="en-US" sz="820" dirty="0"/>
+              <a:t>3. GAP-03 (Hop 3) • Per-Tenant Rate Quotas</a:t>
+            </a:r>
+            <a:endParaRPr lang="en-US" sz="760" dirty="0"/>
           </a:p>
         </p:txBody>
       </p:sp>
@@ -6733,7 +6739,7 @@
                 <a:ea typeface="Roboto" pitchFamily="34" charset="-122"/>
                 <a:cs typeface="Roboto" pitchFamily="34" charset="-120"/>
               </a:rPr>
-              <a:t>WS2 Test 6 PASS (HTTP 429 on 500-RPM flood; budget clamped to 4k) • Target GA: Q4 2026 (Vertex AI quota system enforces regional pro…</a:t>
+              <a:t>WS2 Test 6 PASS (HTTP 429 on 500-RPM flood; budget clamped to 4k) • Target GA: Q4 2026</a:t>
             </a:r>
             <a:endParaRPr lang="en-US" sz="740" dirty="0"/>
           </a:p>
@@ -6804,14 +6810,16 @@
           <a:ln/>
         </p:spPr>
         <p:txBody>
-          <a:bodyPr wrap="square" rtlCol="0" anchor="ctr"/>
+          <a:bodyPr wrap="square" rtlCol="0" anchor="ctr">
+            <a:normAutofit/>
+          </a:bodyPr>
           <a:lstStyle/>
           <a:p>
             <a:pPr indent="0" marL="0">
               <a:buNone/>
             </a:pPr>
             <a:r>
-              <a:rPr lang="en-US" sz="820" b="1" dirty="0">
+              <a:rPr lang="en-US" sz="760" b="1" dirty="0">
                 <a:solidFill>
                   <a:srgbClr val="3C4043"/>
                 </a:solidFill>
@@ -6819,9 +6827,9 @@
                 <a:ea typeface="Google Sans" pitchFamily="34" charset="-122"/>
                 <a:cs typeface="Google Sans" pitchFamily="34" charset="-120"/>
               </a:rPr>
-              <a:t>4. GAP-04 (Hop 1/2) • Multi-IdP 3LO B…</a:t>
-            </a:r>
-            <a:endParaRPr lang="en-US" sz="820" dirty="0"/>
+              <a:t>4. GAP-04 (Hop 1/2) • Multi-IdP 3LO Broker</a:t>
+            </a:r>
+            <a:endParaRPr lang="en-US" sz="760" dirty="0"/>
           </a:p>
         </p:txBody>
       </p:sp>
@@ -6860,7 +6868,7 @@
                 <a:ea typeface="Roboto" pitchFamily="34" charset="-122"/>
                 <a:cs typeface="Roboto" pitchFamily="34" charset="-120"/>
               </a:rPr>
-              <a:t>WS2 Test 10 PASS (HTTP 401 step-up challenge -&gt; 200 OK ServiceNow) • Target GA: Q4 2026 (External Microsoft Entra ID OIDC tokens req…</a:t>
+              <a:t>WS2 Test 10 PASS (HTTP 401 step-up challenge -&gt; 200 OK ServiceNow) • Target GA: Q4 2026</a:t>
             </a:r>
             <a:endParaRPr lang="en-US" sz="740" dirty="0"/>
           </a:p>
@@ -20516,975 +20524,7 @@
       </p:sp>
       <p:sp>
         <p:nvSpPr>
-          <p:cNvPr id="185" name="Text 163"/>
-          <p:cNvSpPr/>
-          <p:nvPr/>
-        </p:nvSpPr>
-        <p:spPr>
-          <a:xfrm>
-            <a:off x="5339182" y="3352190"/>
-            <a:ext cx="760781" cy="219456"/>
-          </a:xfrm>
-          <a:prstGeom prst="rect">
-            <a:avLst/>
-          </a:prstGeom>
-          <a:noFill/>
-          <a:ln/>
-        </p:spPr>
-        <p:txBody>
-          <a:bodyPr wrap="square" lIns="0" tIns="0" rIns="0" bIns="0" rtlCol="0" anchor="ctr">
-            <a:normAutofit/>
-          </a:bodyPr>
-          <a:lstStyle/>
-          <a:p>
-            <a:pPr algn="l" indent="0" marL="0">
-              <a:lnSpc>
-                <a:spcPct val="88000"/>
-              </a:lnSpc>
-              <a:buNone/>
-            </a:pPr>
-            <a:r>
-              <a:rPr lang="en-US" sz="500" b="1" dirty="0">
-                <a:solidFill>
-                  <a:srgbClr val="202124"/>
-                </a:solidFill>
-                <a:latin typeface="Arial" pitchFamily="34" charset="0"/>
-                <a:ea typeface="Arial" pitchFamily="34" charset="-122"/>
-                <a:cs typeface="Arial" pitchFamily="34" charset="-120"/>
-              </a:rPr>
-              <a:t>Security, OTel &amp; FinOps</a:t>
-            </a:r>
-            <a:endParaRPr lang="en-US" sz="500" dirty="0"/>
-          </a:p>
-          <a:p>
-            <a:pPr algn="l" indent="0" marL="0">
-              <a:lnSpc>
-                <a:spcPct val="88000"/>
-              </a:lnSpc>
-              <a:buNone/>
-            </a:pPr>
-            <a:r>
-              <a:rPr lang="en-US" sz="440" dirty="0">
-                <a:solidFill>
-                  <a:srgbClr val="202124"/>
-                </a:solidFill>
-                <a:latin typeface="Arial" pitchFamily="34" charset="0"/>
-                <a:ea typeface="Arial" pitchFamily="34" charset="-122"/>
-                <a:cs typeface="Arial" pitchFamily="34" charset="-120"/>
-              </a:rPr>
-              <a:t>chargeback telemetry</a:t>
-            </a:r>
-            <a:endParaRPr lang="en-US" sz="500" dirty="0"/>
-          </a:p>
-        </p:txBody>
-      </p:sp>
-      <p:sp>
-        <p:nvSpPr>
-          <p:cNvPr id="186" name="Text 164"/>
-          <p:cNvSpPr/>
-          <p:nvPr/>
-        </p:nvSpPr>
-        <p:spPr>
-          <a:xfrm>
-            <a:off x="2691994" y="4813402"/>
-            <a:ext cx="782726" cy="219456"/>
-          </a:xfrm>
-          <a:prstGeom prst="rect">
-            <a:avLst/>
-          </a:prstGeom>
-          <a:noFill/>
-          <a:ln/>
-        </p:spPr>
-        <p:txBody>
-          <a:bodyPr wrap="square" lIns="0" tIns="0" rIns="0" bIns="0" rtlCol="0" anchor="ctr">
-            <a:normAutofit/>
-          </a:bodyPr>
-          <a:lstStyle/>
-          <a:p>
-            <a:pPr algn="ctr" indent="0" marL="0">
-              <a:lnSpc>
-                <a:spcPct val="88000"/>
-              </a:lnSpc>
-              <a:buNone/>
-            </a:pPr>
-            <a:r>
-              <a:rPr lang="en-US" sz="500" b="1" dirty="0">
-                <a:solidFill>
-                  <a:srgbClr val="202124"/>
-                </a:solidFill>
-                <a:latin typeface="Arial" pitchFamily="34" charset="0"/>
-                <a:ea typeface="Arial" pitchFamily="34" charset="-122"/>
-                <a:cs typeface="Arial" pitchFamily="34" charset="-120"/>
-              </a:rPr>
-              <a:t>Scoped</a:t>
-            </a:r>
-            <a:endParaRPr lang="en-US" sz="500" dirty="0"/>
-          </a:p>
-          <a:p>
-            <a:pPr algn="ctr" indent="0" marL="0">
-              <a:lnSpc>
-                <a:spcPct val="88000"/>
-              </a:lnSpc>
-              <a:buNone/>
-            </a:pPr>
-            <a:r>
-              <a:rPr lang="en-US" sz="440" dirty="0">
-                <a:solidFill>
-                  <a:srgbClr val="202124"/>
-                </a:solidFill>
-                <a:latin typeface="Arial" pitchFamily="34" charset="0"/>
-                <a:ea typeface="Arial" pitchFamily="34" charset="-122"/>
-                <a:cs typeface="Arial" pitchFamily="34" charset="-120"/>
-              </a:rPr>
-              <a:t>MCP &amp; RAG</a:t>
-            </a:r>
-            <a:endParaRPr lang="en-US" sz="500" dirty="0"/>
-          </a:p>
-        </p:txBody>
-      </p:sp>
-      <p:sp>
-        <p:nvSpPr>
-          <p:cNvPr id="187" name="Text 165"/>
-          <p:cNvSpPr/>
-          <p:nvPr/>
-        </p:nvSpPr>
-        <p:spPr>
-          <a:xfrm>
-            <a:off x="2691994" y="5447995"/>
-            <a:ext cx="782726" cy="219456"/>
-          </a:xfrm>
-          <a:prstGeom prst="rect">
-            <a:avLst/>
-          </a:prstGeom>
-          <a:noFill/>
-          <a:ln/>
-        </p:spPr>
-        <p:txBody>
-          <a:bodyPr wrap="square" lIns="0" tIns="0" rIns="0" bIns="0" rtlCol="0" anchor="ctr">
-            <a:normAutofit/>
-          </a:bodyPr>
-          <a:lstStyle/>
-          <a:p>
-            <a:pPr algn="ctr" indent="0" marL="0">
-              <a:lnSpc>
-                <a:spcPct val="88000"/>
-              </a:lnSpc>
-              <a:buNone/>
-            </a:pPr>
-            <a:r>
-              <a:rPr lang="en-US" sz="500" b="1" dirty="0">
-                <a:solidFill>
-                  <a:srgbClr val="202124"/>
-                </a:solidFill>
-                <a:latin typeface="Arial" pitchFamily="34" charset="0"/>
-                <a:ea typeface="Arial" pitchFamily="34" charset="-122"/>
-                <a:cs typeface="Arial" pitchFamily="34" charset="-120"/>
-              </a:rPr>
-              <a:t>SET LOCAL</a:t>
-            </a:r>
-            <a:endParaRPr lang="en-US" sz="500" dirty="0"/>
-          </a:p>
-          <a:p>
-            <a:pPr algn="ctr" indent="0" marL="0">
-              <a:lnSpc>
-                <a:spcPct val="88000"/>
-              </a:lnSpc>
-              <a:buNone/>
-            </a:pPr>
-            <a:r>
-              <a:rPr lang="en-US" sz="440" dirty="0">
-                <a:solidFill>
-                  <a:srgbClr val="202124"/>
-                </a:solidFill>
-                <a:latin typeface="Arial" pitchFamily="34" charset="0"/>
-                <a:ea typeface="Arial" pitchFamily="34" charset="-122"/>
-                <a:cs typeface="Arial" pitchFamily="34" charset="-120"/>
-              </a:rPr>
-              <a:t>current_tenant</a:t>
-            </a:r>
-            <a:endParaRPr lang="en-US" sz="500" dirty="0"/>
-          </a:p>
-        </p:txBody>
-      </p:sp>
-      <p:sp>
-        <p:nvSpPr>
-          <p:cNvPr id="188" name="Text 166"/>
-          <p:cNvSpPr/>
-          <p:nvPr/>
-        </p:nvSpPr>
-        <p:spPr>
-          <a:xfrm>
-            <a:off x="5056632" y="4813402"/>
-            <a:ext cx="782726" cy="219456"/>
-          </a:xfrm>
-          <a:prstGeom prst="rect">
-            <a:avLst/>
-          </a:prstGeom>
-          <a:noFill/>
-          <a:ln/>
-        </p:spPr>
-        <p:txBody>
-          <a:bodyPr wrap="square" lIns="0" tIns="0" rIns="0" bIns="0" rtlCol="0" anchor="ctr">
-            <a:normAutofit/>
-          </a:bodyPr>
-          <a:lstStyle/>
-          <a:p>
-            <a:pPr algn="ctr" indent="0" marL="0">
-              <a:lnSpc>
-                <a:spcPct val="88000"/>
-              </a:lnSpc>
-              <a:buNone/>
-            </a:pPr>
-            <a:r>
-              <a:rPr lang="en-US" sz="500" b="1" dirty="0">
-                <a:solidFill>
-                  <a:srgbClr val="202124"/>
-                </a:solidFill>
-                <a:latin typeface="Arial" pitchFamily="34" charset="0"/>
-                <a:ea typeface="Arial" pitchFamily="34" charset="-122"/>
-                <a:cs typeface="Arial" pitchFamily="34" charset="-120"/>
-              </a:rPr>
-              <a:t>Air-Gapped</a:t>
-            </a:r>
-            <a:endParaRPr lang="en-US" sz="500" dirty="0"/>
-          </a:p>
-          <a:p>
-            <a:pPr algn="ctr" indent="0" marL="0">
-              <a:lnSpc>
-                <a:spcPct val="88000"/>
-              </a:lnSpc>
-              <a:buNone/>
-            </a:pPr>
-            <a:r>
-              <a:rPr lang="en-US" sz="440" dirty="0">
-                <a:solidFill>
-                  <a:srgbClr val="202124"/>
-                </a:solidFill>
-                <a:latin typeface="Arial" pitchFamily="34" charset="0"/>
-                <a:ea typeface="Arial" pitchFamily="34" charset="-122"/>
-                <a:cs typeface="Arial" pitchFamily="34" charset="-120"/>
-              </a:rPr>
-              <a:t>Silo RAG</a:t>
-            </a:r>
-            <a:endParaRPr lang="en-US" sz="500" dirty="0"/>
-          </a:p>
-        </p:txBody>
-      </p:sp>
-      <p:sp>
-        <p:nvSpPr>
-          <p:cNvPr id="189" name="Text 167"/>
-          <p:cNvSpPr/>
-          <p:nvPr/>
-        </p:nvSpPr>
-        <p:spPr>
-          <a:xfrm>
-            <a:off x="5056632" y="5447995"/>
-            <a:ext cx="782726" cy="219456"/>
-          </a:xfrm>
-          <a:prstGeom prst="rect">
-            <a:avLst/>
-          </a:prstGeom>
-          <a:noFill/>
-          <a:ln/>
-        </p:spPr>
-        <p:txBody>
-          <a:bodyPr wrap="square" lIns="0" tIns="0" rIns="0" bIns="0" rtlCol="0" anchor="ctr">
-            <a:normAutofit/>
-          </a:bodyPr>
-          <a:lstStyle/>
-          <a:p>
-            <a:pPr algn="ctr" indent="0" marL="0">
-              <a:lnSpc>
-                <a:spcPct val="88000"/>
-              </a:lnSpc>
-              <a:buNone/>
-            </a:pPr>
-            <a:r>
-              <a:rPr lang="en-US" sz="500" b="1" dirty="0">
-                <a:solidFill>
-                  <a:srgbClr val="202124"/>
-                </a:solidFill>
-                <a:latin typeface="Arial" pitchFamily="34" charset="0"/>
-                <a:ea typeface="Arial" pitchFamily="34" charset="-122"/>
-                <a:cs typeface="Arial" pitchFamily="34" charset="-120"/>
-              </a:rPr>
-              <a:t>CMEK-Encrypted</a:t>
-            </a:r>
-            <a:endParaRPr lang="en-US" sz="500" dirty="0"/>
-          </a:p>
-          <a:p>
-            <a:pPr algn="ctr" indent="0" marL="0">
-              <a:lnSpc>
-                <a:spcPct val="88000"/>
-              </a:lnSpc>
-              <a:buNone/>
-            </a:pPr>
-            <a:r>
-              <a:rPr lang="en-US" sz="440" dirty="0">
-                <a:solidFill>
-                  <a:srgbClr val="202124"/>
-                </a:solidFill>
-                <a:latin typeface="Arial" pitchFamily="34" charset="0"/>
-                <a:ea typeface="Arial" pitchFamily="34" charset="-122"/>
-                <a:cs typeface="Arial" pitchFamily="34" charset="-120"/>
-              </a:rPr>
-              <a:t>State &amp; Tools</a:t>
-            </a:r>
-            <a:endParaRPr lang="en-US" sz="500" dirty="0"/>
-          </a:p>
-        </p:txBody>
-      </p:sp>
-      <p:sp>
-        <p:nvSpPr>
-          <p:cNvPr id="190" name="Text 168"/>
-          <p:cNvSpPr/>
-          <p:nvPr/>
-        </p:nvSpPr>
-        <p:spPr>
-          <a:xfrm>
-            <a:off x="1757477" y="5598871"/>
-            <a:ext cx="686714" cy="219456"/>
-          </a:xfrm>
-          <a:prstGeom prst="rect">
-            <a:avLst/>
-          </a:prstGeom>
-          <a:noFill/>
-          <a:ln/>
-        </p:spPr>
-        <p:txBody>
-          <a:bodyPr wrap="square" lIns="0" tIns="0" rIns="0" bIns="0" rtlCol="0" anchor="ctr">
-            <a:normAutofit/>
-          </a:bodyPr>
-          <a:lstStyle/>
-          <a:p>
-            <a:pPr algn="l" indent="0" marL="0">
-              <a:lnSpc>
-                <a:spcPct val="88000"/>
-              </a:lnSpc>
-              <a:buNone/>
-            </a:pPr>
-            <a:r>
-              <a:rPr lang="en-US" sz="500" b="1" dirty="0">
-                <a:solidFill>
-                  <a:srgbClr val="202124"/>
-                </a:solidFill>
-                <a:latin typeface="Arial" pitchFamily="34" charset="0"/>
-                <a:ea typeface="Arial" pitchFamily="34" charset="-122"/>
-                <a:cs typeface="Arial" pitchFamily="34" charset="-120"/>
-              </a:rPr>
-              <a:t>Generates</a:t>
-            </a:r>
-            <a:endParaRPr lang="en-US" sz="500" dirty="0"/>
-          </a:p>
-          <a:p>
-            <a:pPr algn="l" indent="0" marL="0">
-              <a:lnSpc>
-                <a:spcPct val="88000"/>
-              </a:lnSpc>
-              <a:buNone/>
-            </a:pPr>
-            <a:r>
-              <a:rPr lang="en-US" sz="440" dirty="0">
-                <a:solidFill>
-                  <a:srgbClr val="202124"/>
-                </a:solidFill>
-                <a:latin typeface="Arial" pitchFamily="34" charset="0"/>
-                <a:ea typeface="Arial" pitchFamily="34" charset="-122"/>
-                <a:cs typeface="Arial" pitchFamily="34" charset="-120"/>
-              </a:rPr>
-              <a:t>response</a:t>
-            </a:r>
-            <a:endParaRPr lang="en-US" sz="500" dirty="0"/>
-          </a:p>
-        </p:txBody>
-      </p:sp>
-      <p:sp>
-        <p:nvSpPr>
-          <p:cNvPr id="191" name="Text 169"/>
-          <p:cNvSpPr/>
-          <p:nvPr/>
-        </p:nvSpPr>
-        <p:spPr>
-          <a:xfrm>
-            <a:off x="3905402" y="3348533"/>
-            <a:ext cx="738835" cy="219456"/>
-          </a:xfrm>
-          <a:prstGeom prst="rect">
-            <a:avLst/>
-          </a:prstGeom>
-          <a:noFill/>
-          <a:ln/>
-        </p:spPr>
-        <p:txBody>
-          <a:bodyPr wrap="square" lIns="0" tIns="0" rIns="0" bIns="0" rtlCol="0" anchor="ctr">
-            <a:normAutofit/>
-          </a:bodyPr>
-          <a:lstStyle/>
-          <a:p>
-            <a:pPr algn="l" indent="0" marL="0">
-              <a:lnSpc>
-                <a:spcPct val="88000"/>
-              </a:lnSpc>
-              <a:buNone/>
-            </a:pPr>
-            <a:r>
-              <a:rPr lang="en-US" sz="500" b="1" dirty="0">
-                <a:solidFill>
-                  <a:srgbClr val="202124"/>
-                </a:solidFill>
-                <a:latin typeface="Arial" pitchFamily="34" charset="0"/>
-                <a:ea typeface="Arial" pitchFamily="34" charset="-122"/>
-                <a:cs typeface="Arial" pitchFamily="34" charset="-120"/>
-              </a:rPr>
-              <a:t>Sanitized response</a:t>
-            </a:r>
-            <a:endParaRPr lang="en-US" sz="500" dirty="0"/>
-          </a:p>
-          <a:p>
-            <a:pPr algn="l" indent="0" marL="0">
-              <a:lnSpc>
-                <a:spcPct val="88000"/>
-              </a:lnSpc>
-              <a:buNone/>
-            </a:pPr>
-            <a:r>
-              <a:rPr lang="en-US" sz="440" dirty="0">
-                <a:solidFill>
-                  <a:srgbClr val="202124"/>
-                </a:solidFill>
-                <a:latin typeface="Arial" pitchFamily="34" charset="0"/>
-                <a:ea typeface="Arial" pitchFamily="34" charset="-122"/>
-                <a:cs typeface="Arial" pitchFamily="34" charset="-120"/>
-              </a:rPr>
-              <a:t>with SDP redaction</a:t>
-            </a:r>
-            <a:endParaRPr lang="en-US" sz="500" dirty="0"/>
-          </a:p>
-        </p:txBody>
-      </p:sp>
-      <p:sp>
-        <p:nvSpPr>
-          <p:cNvPr id="192" name="Text 170"/>
-          <p:cNvSpPr/>
-          <p:nvPr/>
-        </p:nvSpPr>
-        <p:spPr>
-          <a:xfrm>
-            <a:off x="2983687" y="3348533"/>
-            <a:ext cx="669341" cy="219456"/>
-          </a:xfrm>
-          <a:prstGeom prst="rect">
-            <a:avLst/>
-          </a:prstGeom>
-          <a:noFill/>
-          <a:ln/>
-        </p:spPr>
-        <p:txBody>
-          <a:bodyPr wrap="square" lIns="0" tIns="0" rIns="0" bIns="0" rtlCol="0" anchor="ctr">
-            <a:normAutofit/>
-          </a:bodyPr>
-          <a:lstStyle/>
-          <a:p>
-            <a:pPr algn="l" indent="0" marL="0">
-              <a:lnSpc>
-                <a:spcPct val="88000"/>
-              </a:lnSpc>
-              <a:buNone/>
-            </a:pPr>
-            <a:r>
-              <a:rPr lang="en-US" sz="500" b="1" dirty="0">
-                <a:solidFill>
-                  <a:srgbClr val="202124"/>
-                </a:solidFill>
-                <a:latin typeface="Arial" pitchFamily="34" charset="0"/>
-                <a:ea typeface="Arial" pitchFamily="34" charset="-122"/>
-                <a:cs typeface="Arial" pitchFamily="34" charset="-120"/>
-              </a:rPr>
-              <a:t>Route by tenant tier</a:t>
-            </a:r>
-            <a:endParaRPr lang="en-US" sz="500" dirty="0"/>
-          </a:p>
-          <a:p>
-            <a:pPr algn="l" indent="0" marL="0">
-              <a:lnSpc>
-                <a:spcPct val="88000"/>
-              </a:lnSpc>
-              <a:buNone/>
-            </a:pPr>
-            <a:r>
-              <a:rPr lang="en-US" sz="440" dirty="0">
-                <a:solidFill>
-                  <a:srgbClr val="202124"/>
-                </a:solidFill>
-                <a:latin typeface="Arial" pitchFamily="34" charset="0"/>
-                <a:ea typeface="Arial" pitchFamily="34" charset="-122"/>
-                <a:cs typeface="Arial" pitchFamily="34" charset="-120"/>
-              </a:rPr>
-              <a:t>(Pool, Silo or PSC)</a:t>
-            </a:r>
-            <a:endParaRPr lang="en-US" sz="500" dirty="0"/>
-          </a:p>
-        </p:txBody>
-      </p:sp>
-      <p:sp>
-        <p:nvSpPr>
-          <p:cNvPr id="193" name="Text 171"/>
-          <p:cNvSpPr/>
-          <p:nvPr/>
-        </p:nvSpPr>
-        <p:spPr>
-          <a:xfrm>
-            <a:off x="2462479" y="2865730"/>
-            <a:ext cx="678485" cy="219456"/>
-          </a:xfrm>
-          <a:prstGeom prst="rect">
-            <a:avLst/>
-          </a:prstGeom>
-          <a:noFill/>
-          <a:ln/>
-        </p:spPr>
-        <p:txBody>
-          <a:bodyPr wrap="square" lIns="0" tIns="0" rIns="0" bIns="0" rtlCol="0" anchor="ctr">
-            <a:normAutofit/>
-          </a:bodyPr>
-          <a:lstStyle/>
-          <a:p>
-            <a:pPr algn="ctr" indent="0" marL="0">
-              <a:lnSpc>
-                <a:spcPct val="88000"/>
-              </a:lnSpc>
-              <a:buNone/>
-            </a:pPr>
-            <a:r>
-              <a:rPr lang="en-US" sz="500" b="1" dirty="0">
-                <a:solidFill>
-                  <a:srgbClr val="202124"/>
-                </a:solidFill>
-                <a:latin typeface="Arial" pitchFamily="34" charset="0"/>
-                <a:ea typeface="Arial" pitchFamily="34" charset="-122"/>
-                <a:cs typeface="Arial" pitchFamily="34" charset="-120"/>
-              </a:rPr>
-              <a:t>OBO + KMS</a:t>
-            </a:r>
-            <a:endParaRPr lang="en-US" sz="500" dirty="0"/>
-          </a:p>
-          <a:p>
-            <a:pPr algn="ctr" indent="0" marL="0">
-              <a:lnSpc>
-                <a:spcPct val="88000"/>
-              </a:lnSpc>
-              <a:buNone/>
-            </a:pPr>
-            <a:r>
-              <a:rPr lang="en-US" sz="440" dirty="0">
-                <a:solidFill>
-                  <a:srgbClr val="202124"/>
-                </a:solidFill>
-                <a:latin typeface="Arial" pitchFamily="34" charset="0"/>
-                <a:ea typeface="Arial" pitchFamily="34" charset="-122"/>
-                <a:cs typeface="Arial" pitchFamily="34" charset="-120"/>
-              </a:rPr>
-              <a:t>ECDSA sign</a:t>
-            </a:r>
-            <a:endParaRPr lang="en-US" sz="500" dirty="0"/>
-          </a:p>
-        </p:txBody>
-      </p:sp>
-      <p:sp>
-        <p:nvSpPr>
-          <p:cNvPr id="194" name="Text 172"/>
-          <p:cNvSpPr/>
-          <p:nvPr/>
-        </p:nvSpPr>
-        <p:spPr>
-          <a:xfrm>
-            <a:off x="1757477" y="4614062"/>
-            <a:ext cx="686714" cy="121615"/>
-          </a:xfrm>
-          <a:prstGeom prst="rect">
-            <a:avLst/>
-          </a:prstGeom>
-          <a:noFill/>
-          <a:ln/>
-        </p:spPr>
-        <p:txBody>
-          <a:bodyPr wrap="square" lIns="0" tIns="0" rIns="0" bIns="0" rtlCol="0" anchor="ctr">
-            <a:normAutofit/>
-          </a:bodyPr>
-          <a:lstStyle/>
-          <a:p>
-            <a:pPr algn="l" indent="0" marL="0">
-              <a:lnSpc>
-                <a:spcPct val="88000"/>
-              </a:lnSpc>
-              <a:buNone/>
-            </a:pPr>
-            <a:r>
-              <a:rPr lang="en-US" sz="500" b="1" dirty="0">
-                <a:solidFill>
-                  <a:srgbClr val="202124"/>
-                </a:solidFill>
-                <a:latin typeface="Arial" pitchFamily="34" charset="0"/>
-                <a:ea typeface="Arial" pitchFamily="34" charset="-122"/>
-                <a:cs typeface="Arial" pitchFamily="34" charset="-120"/>
-              </a:rPr>
-              <a:t>Sanitize request</a:t>
-            </a:r>
-            <a:endParaRPr lang="en-US" sz="500" dirty="0"/>
-          </a:p>
-        </p:txBody>
-      </p:sp>
-      <p:sp>
-        <p:nvSpPr>
-          <p:cNvPr id="195" name="Text 173"/>
-          <p:cNvSpPr/>
-          <p:nvPr/>
-        </p:nvSpPr>
-        <p:spPr>
-          <a:xfrm>
-            <a:off x="1757477" y="4822546"/>
-            <a:ext cx="686714" cy="121615"/>
-          </a:xfrm>
-          <a:prstGeom prst="rect">
-            <a:avLst/>
-          </a:prstGeom>
-          <a:noFill/>
-          <a:ln/>
-        </p:spPr>
-        <p:txBody>
-          <a:bodyPr wrap="square" lIns="0" tIns="0" rIns="0" bIns="0" rtlCol="0" anchor="ctr">
-            <a:normAutofit/>
-          </a:bodyPr>
-          <a:lstStyle/>
-          <a:p>
-            <a:pPr algn="l" indent="0" marL="0">
-              <a:lnSpc>
-                <a:spcPct val="88000"/>
-              </a:lnSpc>
-              <a:buNone/>
-            </a:pPr>
-            <a:r>
-              <a:rPr lang="en-US" sz="500" b="1" dirty="0">
-                <a:solidFill>
-                  <a:srgbClr val="202124"/>
-                </a:solidFill>
-                <a:latin typeface="Arial" pitchFamily="34" charset="0"/>
-                <a:ea typeface="Arial" pitchFamily="34" charset="-122"/>
-                <a:cs typeface="Arial" pitchFamily="34" charset="-120"/>
-              </a:rPr>
-              <a:t>Sanitize response</a:t>
-            </a:r>
-            <a:endParaRPr lang="en-US" sz="500" dirty="0"/>
-          </a:p>
-        </p:txBody>
-      </p:sp>
-      <p:sp>
-        <p:nvSpPr>
-          <p:cNvPr id="196" name="Text 174"/>
-          <p:cNvSpPr/>
-          <p:nvPr/>
-        </p:nvSpPr>
-        <p:spPr>
-          <a:xfrm>
-            <a:off x="2435962" y="2074774"/>
-            <a:ext cx="495605" cy="219456"/>
-          </a:xfrm>
-          <a:prstGeom prst="rect">
-            <a:avLst/>
-          </a:prstGeom>
-          <a:noFill/>
-          <a:ln/>
-        </p:spPr>
-        <p:txBody>
-          <a:bodyPr wrap="square" lIns="0" tIns="0" rIns="0" bIns="0" rtlCol="0" anchor="ctr">
-            <a:normAutofit/>
-          </a:bodyPr>
-          <a:lstStyle/>
-          <a:p>
-            <a:pPr algn="ctr" indent="0" marL="0">
-              <a:lnSpc>
-                <a:spcPct val="88000"/>
-              </a:lnSpc>
-              <a:buNone/>
-            </a:pPr>
-            <a:r>
-              <a:rPr lang="en-US" sz="500" b="1" dirty="0">
-                <a:solidFill>
-                  <a:srgbClr val="202124"/>
-                </a:solidFill>
-                <a:latin typeface="Arial" pitchFamily="34" charset="0"/>
-                <a:ea typeface="Arial" pitchFamily="34" charset="-122"/>
-                <a:cs typeface="Arial" pitchFamily="34" charset="-120"/>
-              </a:rPr>
-              <a:t>Header &amp; WAF</a:t>
-            </a:r>
-            <a:endParaRPr lang="en-US" sz="500" dirty="0"/>
-          </a:p>
-          <a:p>
-            <a:pPr algn="ctr" indent="0" marL="0">
-              <a:lnSpc>
-                <a:spcPct val="88000"/>
-              </a:lnSpc>
-              <a:buNone/>
-            </a:pPr>
-            <a:r>
-              <a:rPr lang="en-US" sz="440" dirty="0">
-                <a:solidFill>
-                  <a:srgbClr val="202124"/>
-                </a:solidFill>
-                <a:latin typeface="Arial" pitchFamily="34" charset="0"/>
-                <a:ea typeface="Arial" pitchFamily="34" charset="-122"/>
-                <a:cs typeface="Arial" pitchFamily="34" charset="-120"/>
-              </a:rPr>
-              <a:t>policies</a:t>
-            </a:r>
-            <a:endParaRPr lang="en-US" sz="500" dirty="0"/>
-          </a:p>
-        </p:txBody>
-      </p:sp>
-      <p:sp>
-        <p:nvSpPr>
-          <p:cNvPr id="197" name="Text 175"/>
-          <p:cNvSpPr/>
-          <p:nvPr/>
-        </p:nvSpPr>
-        <p:spPr>
-          <a:xfrm>
-            <a:off x="2435962" y="2674620"/>
-            <a:ext cx="495605" cy="219456"/>
-          </a:xfrm>
-          <a:prstGeom prst="rect">
-            <a:avLst/>
-          </a:prstGeom>
-          <a:noFill/>
-          <a:ln/>
-        </p:spPr>
-        <p:txBody>
-          <a:bodyPr wrap="square" lIns="0" tIns="0" rIns="0" bIns="0" rtlCol="0" anchor="ctr">
-            <a:normAutofit/>
-          </a:bodyPr>
-          <a:lstStyle/>
-          <a:p>
-            <a:pPr algn="ctr" indent="0" marL="0">
-              <a:lnSpc>
-                <a:spcPct val="88000"/>
-              </a:lnSpc>
-              <a:buNone/>
-            </a:pPr>
-            <a:r>
-              <a:rPr lang="en-US" sz="500" b="1" dirty="0">
-                <a:solidFill>
-                  <a:srgbClr val="202124"/>
-                </a:solidFill>
-                <a:latin typeface="Arial" pitchFamily="34" charset="0"/>
-                <a:ea typeface="Arial" pitchFamily="34" charset="-122"/>
-                <a:cs typeface="Arial" pitchFamily="34" charset="-120"/>
-              </a:rPr>
-              <a:t>Sanitize</a:t>
-            </a:r>
-            <a:endParaRPr lang="en-US" sz="500" dirty="0"/>
-          </a:p>
-          <a:p>
-            <a:pPr algn="ctr" indent="0" marL="0">
-              <a:lnSpc>
-                <a:spcPct val="88000"/>
-              </a:lnSpc>
-              <a:buNone/>
-            </a:pPr>
-            <a:r>
-              <a:rPr lang="en-US" sz="440" dirty="0">
-                <a:solidFill>
-                  <a:srgbClr val="202124"/>
-                </a:solidFill>
-                <a:latin typeface="Arial" pitchFamily="34" charset="0"/>
-                <a:ea typeface="Arial" pitchFamily="34" charset="-122"/>
-                <a:cs typeface="Arial" pitchFamily="34" charset="-120"/>
-              </a:rPr>
-              <a:t>prompt</a:t>
-            </a:r>
-            <a:endParaRPr lang="en-US" sz="500" dirty="0"/>
-          </a:p>
-        </p:txBody>
-      </p:sp>
-      <p:sp>
-        <p:nvSpPr>
-          <p:cNvPr id="198" name="Text 176"/>
-          <p:cNvSpPr/>
-          <p:nvPr/>
-        </p:nvSpPr>
-        <p:spPr>
-          <a:xfrm>
-            <a:off x="3888029" y="1153973"/>
-            <a:ext cx="443484" cy="121615"/>
-          </a:xfrm>
-          <a:prstGeom prst="rect">
-            <a:avLst/>
-          </a:prstGeom>
-          <a:noFill/>
-          <a:ln/>
-        </p:spPr>
-        <p:txBody>
-          <a:bodyPr wrap="square" lIns="0" tIns="0" rIns="0" bIns="0" rtlCol="0" anchor="ctr">
-            <a:normAutofit/>
-          </a:bodyPr>
-          <a:lstStyle/>
-          <a:p>
-            <a:pPr algn="l" indent="0" marL="0">
-              <a:lnSpc>
-                <a:spcPct val="88000"/>
-              </a:lnSpc>
-              <a:buNone/>
-            </a:pPr>
-            <a:r>
-              <a:rPr lang="en-US" sz="500" b="1" dirty="0">
-                <a:solidFill>
-                  <a:srgbClr val="202124"/>
-                </a:solidFill>
-                <a:latin typeface="Arial" pitchFamily="34" charset="0"/>
-                <a:ea typeface="Arial" pitchFamily="34" charset="-122"/>
-                <a:cs typeface="Arial" pitchFamily="34" charset="-120"/>
-              </a:rPr>
-              <a:t>Response</a:t>
-            </a:r>
-            <a:endParaRPr lang="en-US" sz="500" dirty="0"/>
-          </a:p>
-        </p:txBody>
-      </p:sp>
-      <p:sp>
-        <p:nvSpPr>
-          <p:cNvPr id="199" name="Text 177"/>
-          <p:cNvSpPr/>
-          <p:nvPr/>
-        </p:nvSpPr>
-        <p:spPr>
-          <a:xfrm>
-            <a:off x="3888029" y="2731313"/>
-            <a:ext cx="443484" cy="121615"/>
-          </a:xfrm>
-          <a:prstGeom prst="rect">
-            <a:avLst/>
-          </a:prstGeom>
-          <a:noFill/>
-          <a:ln/>
-        </p:spPr>
-        <p:txBody>
-          <a:bodyPr wrap="square" lIns="0" tIns="0" rIns="0" bIns="0" rtlCol="0" anchor="ctr">
-            <a:normAutofit/>
-          </a:bodyPr>
-          <a:lstStyle/>
-          <a:p>
-            <a:pPr algn="l" indent="0" marL="0">
-              <a:lnSpc>
-                <a:spcPct val="88000"/>
-              </a:lnSpc>
-              <a:buNone/>
-            </a:pPr>
-            <a:r>
-              <a:rPr lang="en-US" sz="500" b="1" dirty="0">
-                <a:solidFill>
-                  <a:srgbClr val="202124"/>
-                </a:solidFill>
-                <a:latin typeface="Arial" pitchFamily="34" charset="0"/>
-                <a:ea typeface="Arial" pitchFamily="34" charset="-122"/>
-                <a:cs typeface="Arial" pitchFamily="34" charset="-120"/>
-              </a:rPr>
-              <a:t>Response</a:t>
-            </a:r>
-            <a:endParaRPr lang="en-US" sz="500" dirty="0"/>
-          </a:p>
-        </p:txBody>
-      </p:sp>
-      <p:sp>
-        <p:nvSpPr>
-          <p:cNvPr id="200" name="Text 178"/>
-          <p:cNvSpPr/>
-          <p:nvPr/>
-        </p:nvSpPr>
-        <p:spPr>
-          <a:xfrm>
-            <a:off x="3087929" y="1153973"/>
-            <a:ext cx="399593" cy="121615"/>
-          </a:xfrm>
-          <a:prstGeom prst="rect">
-            <a:avLst/>
-          </a:prstGeom>
-          <a:noFill/>
-          <a:ln/>
-        </p:spPr>
-        <p:txBody>
-          <a:bodyPr wrap="square" lIns="0" tIns="0" rIns="0" bIns="0" rtlCol="0" anchor="ctr">
-            <a:normAutofit/>
-          </a:bodyPr>
-          <a:lstStyle/>
-          <a:p>
-            <a:pPr algn="r" indent="0" marL="0">
-              <a:lnSpc>
-                <a:spcPct val="88000"/>
-              </a:lnSpc>
-              <a:buNone/>
-            </a:pPr>
-            <a:r>
-              <a:rPr lang="en-US" sz="500" b="1" dirty="0">
-                <a:solidFill>
-                  <a:srgbClr val="202124"/>
-                </a:solidFill>
-                <a:latin typeface="Arial" pitchFamily="34" charset="0"/>
-                <a:ea typeface="Arial" pitchFamily="34" charset="-122"/>
-                <a:cs typeface="Arial" pitchFamily="34" charset="-120"/>
-              </a:rPr>
-              <a:t>Request</a:t>
-            </a:r>
-            <a:endParaRPr lang="en-US" sz="500" dirty="0"/>
-          </a:p>
-        </p:txBody>
-      </p:sp>
-      <p:sp>
-        <p:nvSpPr>
-          <p:cNvPr id="201" name="Text 179"/>
-          <p:cNvSpPr/>
-          <p:nvPr/>
-        </p:nvSpPr>
-        <p:spPr>
-          <a:xfrm>
-            <a:off x="3087929" y="2731313"/>
-            <a:ext cx="399593" cy="121615"/>
-          </a:xfrm>
-          <a:prstGeom prst="rect">
-            <a:avLst/>
-          </a:prstGeom>
-          <a:noFill/>
-          <a:ln/>
-        </p:spPr>
-        <p:txBody>
-          <a:bodyPr wrap="square" lIns="0" tIns="0" rIns="0" bIns="0" rtlCol="0" anchor="ctr">
-            <a:normAutofit/>
-          </a:bodyPr>
-          <a:lstStyle/>
-          <a:p>
-            <a:pPr algn="r" indent="0" marL="0">
-              <a:lnSpc>
-                <a:spcPct val="88000"/>
-              </a:lnSpc>
-              <a:buNone/>
-            </a:pPr>
-            <a:r>
-              <a:rPr lang="en-US" sz="500" b="1" dirty="0">
-                <a:solidFill>
-                  <a:srgbClr val="202124"/>
-                </a:solidFill>
-                <a:latin typeface="Arial" pitchFamily="34" charset="0"/>
-                <a:ea typeface="Arial" pitchFamily="34" charset="-122"/>
-                <a:cs typeface="Arial" pitchFamily="34" charset="-120"/>
-              </a:rPr>
-              <a:t>Request</a:t>
-            </a:r>
-            <a:endParaRPr lang="en-US" sz="500" dirty="0"/>
-          </a:p>
-        </p:txBody>
-      </p:sp>
-      <p:sp>
-        <p:nvSpPr>
-          <p:cNvPr id="202" name="Shape 180"/>
+          <p:cNvPr id="185" name="Shape 163"/>
           <p:cNvSpPr/>
           <p:nvPr/>
         </p:nvSpPr>
@@ -21509,7 +20549,7 @@
       </p:sp>
       <p:sp>
         <p:nvSpPr>
-          <p:cNvPr id="203" name="Text 181"/>
+          <p:cNvPr id="186" name="Text 164"/>
           <p:cNvSpPr/>
           <p:nvPr/>
         </p:nvSpPr>
@@ -21548,7 +20588,7 @@
       </p:sp>
       <p:sp>
         <p:nvSpPr>
-          <p:cNvPr id="204" name="Shape 182"/>
+          <p:cNvPr id="187" name="Shape 165"/>
           <p:cNvSpPr/>
           <p:nvPr/>
         </p:nvSpPr>
@@ -21573,7 +20613,7 @@
       </p:sp>
       <p:sp>
         <p:nvSpPr>
-          <p:cNvPr id="205" name="Text 183"/>
+          <p:cNvPr id="188" name="Text 166"/>
           <p:cNvSpPr/>
           <p:nvPr/>
         </p:nvSpPr>
@@ -21612,7 +20652,7 @@
       </p:sp>
       <p:sp>
         <p:nvSpPr>
-          <p:cNvPr id="206" name="Shape 184"/>
+          <p:cNvPr id="189" name="Shape 167"/>
           <p:cNvSpPr/>
           <p:nvPr/>
         </p:nvSpPr>
@@ -21637,7 +20677,7 @@
       </p:sp>
       <p:sp>
         <p:nvSpPr>
-          <p:cNvPr id="207" name="Text 185"/>
+          <p:cNvPr id="190" name="Text 168"/>
           <p:cNvSpPr/>
           <p:nvPr/>
         </p:nvSpPr>
@@ -21676,7 +20716,7 @@
       </p:sp>
       <p:sp>
         <p:nvSpPr>
-          <p:cNvPr id="208" name="Shape 186"/>
+          <p:cNvPr id="191" name="Shape 169"/>
           <p:cNvSpPr/>
           <p:nvPr/>
         </p:nvSpPr>
@@ -21701,7 +20741,7 @@
       </p:sp>
       <p:sp>
         <p:nvSpPr>
-          <p:cNvPr id="209" name="Text 187"/>
+          <p:cNvPr id="192" name="Text 170"/>
           <p:cNvSpPr/>
           <p:nvPr/>
         </p:nvSpPr>
@@ -21740,7 +20780,7 @@
       </p:sp>
       <p:sp>
         <p:nvSpPr>
-          <p:cNvPr id="210" name="Shape 188"/>
+          <p:cNvPr id="193" name="Shape 171"/>
           <p:cNvSpPr/>
           <p:nvPr/>
         </p:nvSpPr>
@@ -21765,7 +20805,7 @@
       </p:sp>
       <p:sp>
         <p:nvSpPr>
-          <p:cNvPr id="211" name="Text 189"/>
+          <p:cNvPr id="194" name="Text 172"/>
           <p:cNvSpPr/>
           <p:nvPr/>
         </p:nvSpPr>
@@ -21804,7 +20844,7 @@
       </p:sp>
       <p:sp>
         <p:nvSpPr>
-          <p:cNvPr id="212" name="Shape 190"/>
+          <p:cNvPr id="195" name="Shape 173"/>
           <p:cNvSpPr/>
           <p:nvPr/>
         </p:nvSpPr>
@@ -21829,7 +20869,7 @@
       </p:sp>
       <p:sp>
         <p:nvSpPr>
-          <p:cNvPr id="213" name="Text 191"/>
+          <p:cNvPr id="196" name="Text 174"/>
           <p:cNvSpPr/>
           <p:nvPr/>
         </p:nvSpPr>
@@ -21868,7 +20908,7 @@
       </p:sp>
       <p:sp>
         <p:nvSpPr>
-          <p:cNvPr id="214" name="Shape 192"/>
+          <p:cNvPr id="197" name="Shape 175"/>
           <p:cNvSpPr/>
           <p:nvPr/>
         </p:nvSpPr>
@@ -21893,7 +20933,7 @@
       </p:sp>
       <p:sp>
         <p:nvSpPr>
-          <p:cNvPr id="215" name="Text 193"/>
+          <p:cNvPr id="198" name="Text 176"/>
           <p:cNvSpPr/>
           <p:nvPr/>
         </p:nvSpPr>
@@ -21932,7 +20972,7 @@
       </p:sp>
       <p:sp>
         <p:nvSpPr>
-          <p:cNvPr id="216" name="Shape 194"/>
+          <p:cNvPr id="199" name="Shape 177"/>
           <p:cNvSpPr/>
           <p:nvPr/>
         </p:nvSpPr>
@@ -21957,7 +20997,7 @@
       </p:sp>
       <p:sp>
         <p:nvSpPr>
-          <p:cNvPr id="217" name="Text 195"/>
+          <p:cNvPr id="200" name="Text 178"/>
           <p:cNvSpPr/>
           <p:nvPr/>
         </p:nvSpPr>
@@ -21996,7 +21036,7 @@
       </p:sp>
       <p:sp>
         <p:nvSpPr>
-          <p:cNvPr id="218" name="Shape 196"/>
+          <p:cNvPr id="201" name="Shape 179"/>
           <p:cNvSpPr/>
           <p:nvPr/>
         </p:nvSpPr>
@@ -22021,7 +21061,7 @@
       </p:sp>
       <p:sp>
         <p:nvSpPr>
-          <p:cNvPr id="219" name="Text 197"/>
+          <p:cNvPr id="202" name="Text 180"/>
           <p:cNvSpPr/>
           <p:nvPr/>
         </p:nvSpPr>
@@ -22060,7 +21100,1434 @@
       </p:sp>
       <p:sp>
         <p:nvSpPr>
+          <p:cNvPr id="203" name="Shape 181"/>
+          <p:cNvSpPr/>
+          <p:nvPr/>
+        </p:nvSpPr>
+        <p:spPr>
+          <a:xfrm>
+            <a:off x="5339182" y="3353105"/>
+            <a:ext cx="760781" cy="217627"/>
+          </a:xfrm>
+          <a:prstGeom prst="roundRect">
+            <a:avLst>
+              <a:gd name="adj" fmla="val 21008"/>
+            </a:avLst>
+          </a:prstGeom>
+          <a:solidFill>
+            <a:srgbClr val="FFFFFF"/>
+          </a:solidFill>
+          <a:ln w="5715">
+            <a:solidFill>
+              <a:srgbClr val="DADCE0"/>
+            </a:solidFill>
+            <a:prstDash val="solid"/>
+          </a:ln>
+        </p:spPr>
+      </p:sp>
+      <p:sp>
+        <p:nvSpPr>
+          <p:cNvPr id="204" name="Text 182"/>
+          <p:cNvSpPr/>
+          <p:nvPr/>
+        </p:nvSpPr>
+        <p:spPr>
+          <a:xfrm>
+            <a:off x="5357470" y="3362249"/>
+            <a:ext cx="724205" cy="199339"/>
+          </a:xfrm>
+          <a:prstGeom prst="rect">
+            <a:avLst/>
+          </a:prstGeom>
+          <a:noFill/>
+          <a:ln/>
+        </p:spPr>
+        <p:txBody>
+          <a:bodyPr wrap="square" lIns="0" tIns="0" rIns="0" bIns="0" rtlCol="0" anchor="ctr">
+            <a:normAutofit/>
+          </a:bodyPr>
+          <a:lstStyle/>
+          <a:p>
+            <a:pPr algn="ctr" indent="0" marL="0">
+              <a:lnSpc>
+                <a:spcPct val="86000"/>
+              </a:lnSpc>
+              <a:buNone/>
+            </a:pPr>
+            <a:r>
+              <a:rPr lang="en-US" sz="480" b="1" dirty="0">
+                <a:solidFill>
+                  <a:srgbClr val="202124"/>
+                </a:solidFill>
+                <a:latin typeface="Arial" pitchFamily="34" charset="0"/>
+                <a:ea typeface="Arial" pitchFamily="34" charset="-122"/>
+                <a:cs typeface="Arial" pitchFamily="34" charset="-120"/>
+              </a:rPr>
+              <a:t>Security, OTel &amp; FinOps</a:t>
+            </a:r>
+            <a:endParaRPr lang="en-US" sz="480" dirty="0"/>
+          </a:p>
+          <a:p>
+            <a:pPr algn="ctr" indent="0" marL="0">
+              <a:lnSpc>
+                <a:spcPct val="86000"/>
+              </a:lnSpc>
+              <a:buNone/>
+            </a:pPr>
+            <a:r>
+              <a:rPr lang="en-US" sz="420" dirty="0">
+                <a:solidFill>
+                  <a:srgbClr val="202124"/>
+                </a:solidFill>
+                <a:latin typeface="Arial" pitchFamily="34" charset="0"/>
+                <a:ea typeface="Arial" pitchFamily="34" charset="-122"/>
+                <a:cs typeface="Arial" pitchFamily="34" charset="-120"/>
+              </a:rPr>
+              <a:t>chargeback telemetry</a:t>
+            </a:r>
+            <a:endParaRPr lang="en-US" sz="480" dirty="0"/>
+          </a:p>
+        </p:txBody>
+      </p:sp>
+      <p:sp>
+        <p:nvSpPr>
+          <p:cNvPr id="205" name="Shape 183"/>
+          <p:cNvSpPr/>
+          <p:nvPr/>
+        </p:nvSpPr>
+        <p:spPr>
+          <a:xfrm>
+            <a:off x="2827325" y="4817059"/>
+            <a:ext cx="512064" cy="210312"/>
+          </a:xfrm>
+          <a:prstGeom prst="roundRect">
+            <a:avLst>
+              <a:gd name="adj" fmla="val 21739"/>
+            </a:avLst>
+          </a:prstGeom>
+          <a:solidFill>
+            <a:srgbClr val="FFFFFF"/>
+          </a:solidFill>
+          <a:ln w="5715">
+            <a:solidFill>
+              <a:srgbClr val="DADCE0"/>
+            </a:solidFill>
+            <a:prstDash val="solid"/>
+          </a:ln>
+        </p:spPr>
+      </p:sp>
+      <p:sp>
+        <p:nvSpPr>
+          <p:cNvPr id="206" name="Text 184"/>
+          <p:cNvSpPr/>
+          <p:nvPr/>
+        </p:nvSpPr>
+        <p:spPr>
+          <a:xfrm>
+            <a:off x="2845613" y="4826203"/>
+            <a:ext cx="475488" cy="192024"/>
+          </a:xfrm>
+          <a:prstGeom prst="rect">
+            <a:avLst/>
+          </a:prstGeom>
+          <a:noFill/>
+          <a:ln/>
+        </p:spPr>
+        <p:txBody>
+          <a:bodyPr wrap="square" lIns="0" tIns="0" rIns="0" bIns="0" rtlCol="0" anchor="ctr">
+            <a:normAutofit/>
+          </a:bodyPr>
+          <a:lstStyle/>
+          <a:p>
+            <a:pPr algn="ctr" indent="0" marL="0">
+              <a:lnSpc>
+                <a:spcPct val="86000"/>
+              </a:lnSpc>
+              <a:buNone/>
+            </a:pPr>
+            <a:r>
+              <a:rPr lang="en-US" sz="480" b="1" dirty="0">
+                <a:solidFill>
+                  <a:srgbClr val="202124"/>
+                </a:solidFill>
+                <a:latin typeface="Arial" pitchFamily="34" charset="0"/>
+                <a:ea typeface="Arial" pitchFamily="34" charset="-122"/>
+                <a:cs typeface="Arial" pitchFamily="34" charset="-120"/>
+              </a:rPr>
+              <a:t>Scoped</a:t>
+            </a:r>
+            <a:endParaRPr lang="en-US" sz="480" dirty="0"/>
+          </a:p>
+          <a:p>
+            <a:pPr algn="ctr" indent="0" marL="0">
+              <a:lnSpc>
+                <a:spcPct val="86000"/>
+              </a:lnSpc>
+              <a:buNone/>
+            </a:pPr>
+            <a:r>
+              <a:rPr lang="en-US" sz="420" dirty="0">
+                <a:solidFill>
+                  <a:srgbClr val="202124"/>
+                </a:solidFill>
+                <a:latin typeface="Arial" pitchFamily="34" charset="0"/>
+                <a:ea typeface="Arial" pitchFamily="34" charset="-122"/>
+                <a:cs typeface="Arial" pitchFamily="34" charset="-120"/>
+              </a:rPr>
+              <a:t>MCP &amp; RAG</a:t>
+            </a:r>
+            <a:endParaRPr lang="en-US" sz="480" dirty="0"/>
+          </a:p>
+        </p:txBody>
+      </p:sp>
+      <p:sp>
+        <p:nvSpPr>
+          <p:cNvPr id="207" name="Shape 185"/>
+          <p:cNvSpPr/>
+          <p:nvPr/>
+        </p:nvSpPr>
+        <p:spPr>
+          <a:xfrm>
+            <a:off x="2744114" y="5451653"/>
+            <a:ext cx="678485" cy="210312"/>
+          </a:xfrm>
+          <a:prstGeom prst="roundRect">
+            <a:avLst>
+              <a:gd name="adj" fmla="val 21739"/>
+            </a:avLst>
+          </a:prstGeom>
+          <a:solidFill>
+            <a:srgbClr val="FFFFFF"/>
+          </a:solidFill>
+          <a:ln w="5715">
+            <a:solidFill>
+              <a:srgbClr val="DADCE0"/>
+            </a:solidFill>
+            <a:prstDash val="solid"/>
+          </a:ln>
+        </p:spPr>
+      </p:sp>
+      <p:sp>
+        <p:nvSpPr>
+          <p:cNvPr id="208" name="Text 186"/>
+          <p:cNvSpPr/>
+          <p:nvPr/>
+        </p:nvSpPr>
+        <p:spPr>
+          <a:xfrm>
+            <a:off x="2762402" y="5460797"/>
+            <a:ext cx="641909" cy="192024"/>
+          </a:xfrm>
+          <a:prstGeom prst="rect">
+            <a:avLst/>
+          </a:prstGeom>
+          <a:noFill/>
+          <a:ln/>
+        </p:spPr>
+        <p:txBody>
+          <a:bodyPr wrap="square" lIns="0" tIns="0" rIns="0" bIns="0" rtlCol="0" anchor="ctr">
+            <a:normAutofit/>
+          </a:bodyPr>
+          <a:lstStyle/>
+          <a:p>
+            <a:pPr algn="ctr" indent="0" marL="0">
+              <a:lnSpc>
+                <a:spcPct val="86000"/>
+              </a:lnSpc>
+              <a:buNone/>
+            </a:pPr>
+            <a:r>
+              <a:rPr lang="en-US" sz="480" b="1" dirty="0">
+                <a:solidFill>
+                  <a:srgbClr val="202124"/>
+                </a:solidFill>
+                <a:latin typeface="Arial" pitchFamily="34" charset="0"/>
+                <a:ea typeface="Arial" pitchFamily="34" charset="-122"/>
+                <a:cs typeface="Arial" pitchFamily="34" charset="-120"/>
+              </a:rPr>
+              <a:t>SET LOCAL</a:t>
+            </a:r>
+            <a:endParaRPr lang="en-US" sz="480" dirty="0"/>
+          </a:p>
+          <a:p>
+            <a:pPr algn="ctr" indent="0" marL="0">
+              <a:lnSpc>
+                <a:spcPct val="86000"/>
+              </a:lnSpc>
+              <a:buNone/>
+            </a:pPr>
+            <a:r>
+              <a:rPr lang="en-US" sz="420" dirty="0">
+                <a:solidFill>
+                  <a:srgbClr val="202124"/>
+                </a:solidFill>
+                <a:latin typeface="Arial" pitchFamily="34" charset="0"/>
+                <a:ea typeface="Arial" pitchFamily="34" charset="-122"/>
+                <a:cs typeface="Arial" pitchFamily="34" charset="-120"/>
+              </a:rPr>
+              <a:t>current_tenant</a:t>
+            </a:r>
+            <a:endParaRPr lang="en-US" sz="480" dirty="0"/>
+          </a:p>
+        </p:txBody>
+      </p:sp>
+      <p:sp>
+        <p:nvSpPr>
+          <p:cNvPr id="209" name="Shape 187"/>
+          <p:cNvSpPr/>
+          <p:nvPr/>
+        </p:nvSpPr>
+        <p:spPr>
+          <a:xfrm>
+            <a:off x="5187391" y="4817059"/>
+            <a:ext cx="521208" cy="210312"/>
+          </a:xfrm>
+          <a:prstGeom prst="roundRect">
+            <a:avLst>
+              <a:gd name="adj" fmla="val 21739"/>
+            </a:avLst>
+          </a:prstGeom>
+          <a:solidFill>
+            <a:srgbClr val="FFFFFF"/>
+          </a:solidFill>
+          <a:ln w="5715">
+            <a:solidFill>
+              <a:srgbClr val="DADCE0"/>
+            </a:solidFill>
+            <a:prstDash val="solid"/>
+          </a:ln>
+        </p:spPr>
+      </p:sp>
+      <p:sp>
+        <p:nvSpPr>
+          <p:cNvPr id="210" name="Text 188"/>
+          <p:cNvSpPr/>
+          <p:nvPr/>
+        </p:nvSpPr>
+        <p:spPr>
+          <a:xfrm>
+            <a:off x="5205679" y="4826203"/>
+            <a:ext cx="484632" cy="192024"/>
+          </a:xfrm>
+          <a:prstGeom prst="rect">
+            <a:avLst/>
+          </a:prstGeom>
+          <a:noFill/>
+          <a:ln/>
+        </p:spPr>
+        <p:txBody>
+          <a:bodyPr wrap="square" lIns="0" tIns="0" rIns="0" bIns="0" rtlCol="0" anchor="ctr">
+            <a:normAutofit/>
+          </a:bodyPr>
+          <a:lstStyle/>
+          <a:p>
+            <a:pPr algn="ctr" indent="0" marL="0">
+              <a:lnSpc>
+                <a:spcPct val="86000"/>
+              </a:lnSpc>
+              <a:buNone/>
+            </a:pPr>
+            <a:r>
+              <a:rPr lang="en-US" sz="480" b="1" dirty="0">
+                <a:solidFill>
+                  <a:srgbClr val="202124"/>
+                </a:solidFill>
+                <a:latin typeface="Arial" pitchFamily="34" charset="0"/>
+                <a:ea typeface="Arial" pitchFamily="34" charset="-122"/>
+                <a:cs typeface="Arial" pitchFamily="34" charset="-120"/>
+              </a:rPr>
+              <a:t>Air-Gapped</a:t>
+            </a:r>
+            <a:endParaRPr lang="en-US" sz="480" dirty="0"/>
+          </a:p>
+          <a:p>
+            <a:pPr algn="ctr" indent="0" marL="0">
+              <a:lnSpc>
+                <a:spcPct val="86000"/>
+              </a:lnSpc>
+              <a:buNone/>
+            </a:pPr>
+            <a:r>
+              <a:rPr lang="en-US" sz="420" dirty="0">
+                <a:solidFill>
+                  <a:srgbClr val="202124"/>
+                </a:solidFill>
+                <a:latin typeface="Arial" pitchFamily="34" charset="0"/>
+                <a:ea typeface="Arial" pitchFamily="34" charset="-122"/>
+                <a:cs typeface="Arial" pitchFamily="34" charset="-120"/>
+              </a:rPr>
+              <a:t>Silo RAG</a:t>
+            </a:r>
+            <a:endParaRPr lang="en-US" sz="480" dirty="0"/>
+          </a:p>
+        </p:txBody>
+      </p:sp>
+      <p:sp>
+        <p:nvSpPr>
+          <p:cNvPr id="211" name="Shape 189"/>
+          <p:cNvSpPr/>
+          <p:nvPr/>
+        </p:nvSpPr>
+        <p:spPr>
+          <a:xfrm>
+            <a:off x="5108753" y="5451653"/>
+            <a:ext cx="678485" cy="210312"/>
+          </a:xfrm>
+          <a:prstGeom prst="roundRect">
+            <a:avLst>
+              <a:gd name="adj" fmla="val 21739"/>
+            </a:avLst>
+          </a:prstGeom>
+          <a:solidFill>
+            <a:srgbClr val="FFFFFF"/>
+          </a:solidFill>
+          <a:ln w="5715">
+            <a:solidFill>
+              <a:srgbClr val="DADCE0"/>
+            </a:solidFill>
+            <a:prstDash val="solid"/>
+          </a:ln>
+        </p:spPr>
+      </p:sp>
+      <p:sp>
+        <p:nvSpPr>
+          <p:cNvPr id="212" name="Text 190"/>
+          <p:cNvSpPr/>
+          <p:nvPr/>
+        </p:nvSpPr>
+        <p:spPr>
+          <a:xfrm>
+            <a:off x="5127041" y="5460797"/>
+            <a:ext cx="641909" cy="192024"/>
+          </a:xfrm>
+          <a:prstGeom prst="rect">
+            <a:avLst/>
+          </a:prstGeom>
+          <a:noFill/>
+          <a:ln/>
+        </p:spPr>
+        <p:txBody>
+          <a:bodyPr wrap="square" lIns="0" tIns="0" rIns="0" bIns="0" rtlCol="0" anchor="ctr">
+            <a:normAutofit/>
+          </a:bodyPr>
+          <a:lstStyle/>
+          <a:p>
+            <a:pPr algn="ctr" indent="0" marL="0">
+              <a:lnSpc>
+                <a:spcPct val="86000"/>
+              </a:lnSpc>
+              <a:buNone/>
+            </a:pPr>
+            <a:r>
+              <a:rPr lang="en-US" sz="480" b="1" dirty="0">
+                <a:solidFill>
+                  <a:srgbClr val="202124"/>
+                </a:solidFill>
+                <a:latin typeface="Arial" pitchFamily="34" charset="0"/>
+                <a:ea typeface="Arial" pitchFamily="34" charset="-122"/>
+                <a:cs typeface="Arial" pitchFamily="34" charset="-120"/>
+              </a:rPr>
+              <a:t>CMEK-Encrypted</a:t>
+            </a:r>
+            <a:endParaRPr lang="en-US" sz="480" dirty="0"/>
+          </a:p>
+          <a:p>
+            <a:pPr algn="ctr" indent="0" marL="0">
+              <a:lnSpc>
+                <a:spcPct val="86000"/>
+              </a:lnSpc>
+              <a:buNone/>
+            </a:pPr>
+            <a:r>
+              <a:rPr lang="en-US" sz="420" dirty="0">
+                <a:solidFill>
+                  <a:srgbClr val="202124"/>
+                </a:solidFill>
+                <a:latin typeface="Arial" pitchFamily="34" charset="0"/>
+                <a:ea typeface="Arial" pitchFamily="34" charset="-122"/>
+                <a:cs typeface="Arial" pitchFamily="34" charset="-120"/>
+              </a:rPr>
+              <a:t>State &amp; Tools</a:t>
+            </a:r>
+            <a:endParaRPr lang="en-US" sz="480" dirty="0"/>
+          </a:p>
+        </p:txBody>
+      </p:sp>
+      <p:sp>
+        <p:nvSpPr>
+          <p:cNvPr id="213" name="Shape 191"/>
+          <p:cNvSpPr/>
+          <p:nvPr/>
+        </p:nvSpPr>
+        <p:spPr>
+          <a:xfrm>
+            <a:off x="1845259" y="5603443"/>
+            <a:ext cx="512064" cy="210312"/>
+          </a:xfrm>
+          <a:prstGeom prst="roundRect">
+            <a:avLst>
+              <a:gd name="adj" fmla="val 21739"/>
+            </a:avLst>
+          </a:prstGeom>
+          <a:solidFill>
+            <a:srgbClr val="FFFFFF"/>
+          </a:solidFill>
+          <a:ln w="5715">
+            <a:solidFill>
+              <a:srgbClr val="DADCE0"/>
+            </a:solidFill>
+            <a:prstDash val="solid"/>
+          </a:ln>
+        </p:spPr>
+      </p:sp>
+      <p:sp>
+        <p:nvSpPr>
+          <p:cNvPr id="214" name="Text 192"/>
+          <p:cNvSpPr/>
+          <p:nvPr/>
+        </p:nvSpPr>
+        <p:spPr>
+          <a:xfrm>
+            <a:off x="1863547" y="5612587"/>
+            <a:ext cx="475488" cy="192024"/>
+          </a:xfrm>
+          <a:prstGeom prst="rect">
+            <a:avLst/>
+          </a:prstGeom>
+          <a:noFill/>
+          <a:ln/>
+        </p:spPr>
+        <p:txBody>
+          <a:bodyPr wrap="square" lIns="0" tIns="0" rIns="0" bIns="0" rtlCol="0" anchor="ctr">
+            <a:normAutofit/>
+          </a:bodyPr>
+          <a:lstStyle/>
+          <a:p>
+            <a:pPr algn="ctr" indent="0" marL="0">
+              <a:lnSpc>
+                <a:spcPct val="86000"/>
+              </a:lnSpc>
+              <a:buNone/>
+            </a:pPr>
+            <a:r>
+              <a:rPr lang="en-US" sz="480" b="1" dirty="0">
+                <a:solidFill>
+                  <a:srgbClr val="202124"/>
+                </a:solidFill>
+                <a:latin typeface="Arial" pitchFamily="34" charset="0"/>
+                <a:ea typeface="Arial" pitchFamily="34" charset="-122"/>
+                <a:cs typeface="Arial" pitchFamily="34" charset="-120"/>
+              </a:rPr>
+              <a:t>Generates</a:t>
+            </a:r>
+            <a:endParaRPr lang="en-US" sz="480" dirty="0"/>
+          </a:p>
+          <a:p>
+            <a:pPr algn="ctr" indent="0" marL="0">
+              <a:lnSpc>
+                <a:spcPct val="86000"/>
+              </a:lnSpc>
+              <a:buNone/>
+            </a:pPr>
+            <a:r>
+              <a:rPr lang="en-US" sz="420" dirty="0">
+                <a:solidFill>
+                  <a:srgbClr val="202124"/>
+                </a:solidFill>
+                <a:latin typeface="Arial" pitchFamily="34" charset="0"/>
+                <a:ea typeface="Arial" pitchFamily="34" charset="-122"/>
+                <a:cs typeface="Arial" pitchFamily="34" charset="-120"/>
+              </a:rPr>
+              <a:t>response</a:t>
+            </a:r>
+            <a:endParaRPr lang="en-US" sz="480" dirty="0"/>
+          </a:p>
+        </p:txBody>
+      </p:sp>
+      <p:sp>
+        <p:nvSpPr>
+          <p:cNvPr id="215" name="Shape 193"/>
+          <p:cNvSpPr/>
+          <p:nvPr/>
+        </p:nvSpPr>
+        <p:spPr>
+          <a:xfrm>
+            <a:off x="3905402" y="3353105"/>
+            <a:ext cx="738835" cy="210312"/>
+          </a:xfrm>
+          <a:prstGeom prst="roundRect">
+            <a:avLst>
+              <a:gd name="adj" fmla="val 21739"/>
+            </a:avLst>
+          </a:prstGeom>
+          <a:solidFill>
+            <a:srgbClr val="FFFFFF"/>
+          </a:solidFill>
+          <a:ln w="5715">
+            <a:solidFill>
+              <a:srgbClr val="DADCE0"/>
+            </a:solidFill>
+            <a:prstDash val="solid"/>
+          </a:ln>
+        </p:spPr>
+      </p:sp>
+      <p:sp>
+        <p:nvSpPr>
+          <p:cNvPr id="216" name="Text 194"/>
+          <p:cNvSpPr/>
+          <p:nvPr/>
+        </p:nvSpPr>
+        <p:spPr>
+          <a:xfrm>
+            <a:off x="3923690" y="3362249"/>
+            <a:ext cx="702259" cy="192024"/>
+          </a:xfrm>
+          <a:prstGeom prst="rect">
+            <a:avLst/>
+          </a:prstGeom>
+          <a:noFill/>
+          <a:ln/>
+        </p:spPr>
+        <p:txBody>
+          <a:bodyPr wrap="square" lIns="0" tIns="0" rIns="0" bIns="0" rtlCol="0" anchor="ctr">
+            <a:normAutofit/>
+          </a:bodyPr>
+          <a:lstStyle/>
+          <a:p>
+            <a:pPr algn="ctr" indent="0" marL="0">
+              <a:lnSpc>
+                <a:spcPct val="86000"/>
+              </a:lnSpc>
+              <a:buNone/>
+            </a:pPr>
+            <a:r>
+              <a:rPr lang="en-US" sz="480" b="1" dirty="0">
+                <a:solidFill>
+                  <a:srgbClr val="202124"/>
+                </a:solidFill>
+                <a:latin typeface="Arial" pitchFamily="34" charset="0"/>
+                <a:ea typeface="Arial" pitchFamily="34" charset="-122"/>
+                <a:cs typeface="Arial" pitchFamily="34" charset="-120"/>
+              </a:rPr>
+              <a:t>Sanitized response</a:t>
+            </a:r>
+            <a:endParaRPr lang="en-US" sz="480" dirty="0"/>
+          </a:p>
+          <a:p>
+            <a:pPr algn="ctr" indent="0" marL="0">
+              <a:lnSpc>
+                <a:spcPct val="86000"/>
+              </a:lnSpc>
+              <a:buNone/>
+            </a:pPr>
+            <a:r>
+              <a:rPr lang="en-US" sz="420" dirty="0">
+                <a:solidFill>
+                  <a:srgbClr val="202124"/>
+                </a:solidFill>
+                <a:latin typeface="Arial" pitchFamily="34" charset="0"/>
+                <a:ea typeface="Arial" pitchFamily="34" charset="-122"/>
+                <a:cs typeface="Arial" pitchFamily="34" charset="-120"/>
+              </a:rPr>
+              <a:t>with SDP redaction</a:t>
+            </a:r>
+            <a:endParaRPr lang="en-US" sz="480" dirty="0"/>
+          </a:p>
+        </p:txBody>
+      </p:sp>
+      <p:sp>
+        <p:nvSpPr>
+          <p:cNvPr id="217" name="Shape 195"/>
+          <p:cNvSpPr/>
+          <p:nvPr/>
+        </p:nvSpPr>
+        <p:spPr>
+          <a:xfrm>
+            <a:off x="2983687" y="3353105"/>
+            <a:ext cx="669341" cy="210312"/>
+          </a:xfrm>
+          <a:prstGeom prst="roundRect">
+            <a:avLst>
+              <a:gd name="adj" fmla="val 21739"/>
+            </a:avLst>
+          </a:prstGeom>
+          <a:solidFill>
+            <a:srgbClr val="FFFFFF"/>
+          </a:solidFill>
+          <a:ln w="5715">
+            <a:solidFill>
+              <a:srgbClr val="DADCE0"/>
+            </a:solidFill>
+            <a:prstDash val="solid"/>
+          </a:ln>
+        </p:spPr>
+      </p:sp>
+      <p:sp>
+        <p:nvSpPr>
+          <p:cNvPr id="218" name="Text 196"/>
+          <p:cNvSpPr/>
+          <p:nvPr/>
+        </p:nvSpPr>
+        <p:spPr>
+          <a:xfrm>
+            <a:off x="3001975" y="3362249"/>
+            <a:ext cx="632765" cy="192024"/>
+          </a:xfrm>
+          <a:prstGeom prst="rect">
+            <a:avLst/>
+          </a:prstGeom>
+          <a:noFill/>
+          <a:ln/>
+        </p:spPr>
+        <p:txBody>
+          <a:bodyPr wrap="square" lIns="0" tIns="0" rIns="0" bIns="0" rtlCol="0" anchor="ctr">
+            <a:normAutofit/>
+          </a:bodyPr>
+          <a:lstStyle/>
+          <a:p>
+            <a:pPr algn="ctr" indent="0" marL="0">
+              <a:lnSpc>
+                <a:spcPct val="86000"/>
+              </a:lnSpc>
+              <a:buNone/>
+            </a:pPr>
+            <a:r>
+              <a:rPr lang="en-US" sz="480" b="1" dirty="0">
+                <a:solidFill>
+                  <a:srgbClr val="202124"/>
+                </a:solidFill>
+                <a:latin typeface="Arial" pitchFamily="34" charset="0"/>
+                <a:ea typeface="Arial" pitchFamily="34" charset="-122"/>
+                <a:cs typeface="Arial" pitchFamily="34" charset="-120"/>
+              </a:rPr>
+              <a:t>Route by tenant tier</a:t>
+            </a:r>
+            <a:endParaRPr lang="en-US" sz="480" dirty="0"/>
+          </a:p>
+          <a:p>
+            <a:pPr algn="ctr" indent="0" marL="0">
+              <a:lnSpc>
+                <a:spcPct val="86000"/>
+              </a:lnSpc>
+              <a:buNone/>
+            </a:pPr>
+            <a:r>
+              <a:rPr lang="en-US" sz="420" dirty="0">
+                <a:solidFill>
+                  <a:srgbClr val="202124"/>
+                </a:solidFill>
+                <a:latin typeface="Arial" pitchFamily="34" charset="0"/>
+                <a:ea typeface="Arial" pitchFamily="34" charset="-122"/>
+                <a:cs typeface="Arial" pitchFamily="34" charset="-120"/>
+              </a:rPr>
+              <a:t>(Pool, Silo or PSC)</a:t>
+            </a:r>
+            <a:endParaRPr lang="en-US" sz="480" dirty="0"/>
+          </a:p>
+        </p:txBody>
+      </p:sp>
+      <p:sp>
+        <p:nvSpPr>
+          <p:cNvPr id="219" name="Shape 197"/>
+          <p:cNvSpPr/>
+          <p:nvPr/>
+        </p:nvSpPr>
+        <p:spPr>
+          <a:xfrm>
+            <a:off x="2541118" y="2870302"/>
+            <a:ext cx="521208" cy="210312"/>
+          </a:xfrm>
+          <a:prstGeom prst="roundRect">
+            <a:avLst>
+              <a:gd name="adj" fmla="val 21739"/>
+            </a:avLst>
+          </a:prstGeom>
+          <a:solidFill>
+            <a:srgbClr val="FFFFFF"/>
+          </a:solidFill>
+          <a:ln w="5715">
+            <a:solidFill>
+              <a:srgbClr val="DADCE0"/>
+            </a:solidFill>
+            <a:prstDash val="solid"/>
+          </a:ln>
+        </p:spPr>
+      </p:sp>
+      <p:sp>
+        <p:nvSpPr>
           <p:cNvPr id="220" name="Text 198"/>
+          <p:cNvSpPr/>
+          <p:nvPr/>
+        </p:nvSpPr>
+        <p:spPr>
+          <a:xfrm>
+            <a:off x="2559406" y="2879446"/>
+            <a:ext cx="484632" cy="192024"/>
+          </a:xfrm>
+          <a:prstGeom prst="rect">
+            <a:avLst/>
+          </a:prstGeom>
+          <a:noFill/>
+          <a:ln/>
+        </p:spPr>
+        <p:txBody>
+          <a:bodyPr wrap="square" lIns="0" tIns="0" rIns="0" bIns="0" rtlCol="0" anchor="ctr">
+            <a:normAutofit/>
+          </a:bodyPr>
+          <a:lstStyle/>
+          <a:p>
+            <a:pPr algn="ctr" indent="0" marL="0">
+              <a:lnSpc>
+                <a:spcPct val="86000"/>
+              </a:lnSpc>
+              <a:buNone/>
+            </a:pPr>
+            <a:r>
+              <a:rPr lang="en-US" sz="480" b="1" dirty="0">
+                <a:solidFill>
+                  <a:srgbClr val="202124"/>
+                </a:solidFill>
+                <a:latin typeface="Arial" pitchFamily="34" charset="0"/>
+                <a:ea typeface="Arial" pitchFamily="34" charset="-122"/>
+                <a:cs typeface="Arial" pitchFamily="34" charset="-120"/>
+              </a:rPr>
+              <a:t>OBO + KMS</a:t>
+            </a:r>
+            <a:endParaRPr lang="en-US" sz="480" dirty="0"/>
+          </a:p>
+          <a:p>
+            <a:pPr algn="ctr" indent="0" marL="0">
+              <a:lnSpc>
+                <a:spcPct val="86000"/>
+              </a:lnSpc>
+              <a:buNone/>
+            </a:pPr>
+            <a:r>
+              <a:rPr lang="en-US" sz="420" dirty="0">
+                <a:solidFill>
+                  <a:srgbClr val="202124"/>
+                </a:solidFill>
+                <a:latin typeface="Arial" pitchFamily="34" charset="0"/>
+                <a:ea typeface="Arial" pitchFamily="34" charset="-122"/>
+                <a:cs typeface="Arial" pitchFamily="34" charset="-120"/>
+              </a:rPr>
+              <a:t>ECDSA sign</a:t>
+            </a:r>
+            <a:endParaRPr lang="en-US" sz="480" dirty="0"/>
+          </a:p>
+        </p:txBody>
+      </p:sp>
+      <p:sp>
+        <p:nvSpPr>
+          <p:cNvPr id="221" name="Shape 199"/>
+          <p:cNvSpPr/>
+          <p:nvPr/>
+        </p:nvSpPr>
+        <p:spPr>
+          <a:xfrm>
+            <a:off x="1757477" y="4602175"/>
+            <a:ext cx="686714" cy="146304"/>
+          </a:xfrm>
+          <a:prstGeom prst="roundRect">
+            <a:avLst>
+              <a:gd name="adj" fmla="val 31250"/>
+            </a:avLst>
+          </a:prstGeom>
+          <a:solidFill>
+            <a:srgbClr val="FFFFFF"/>
+          </a:solidFill>
+          <a:ln w="5715">
+            <a:solidFill>
+              <a:srgbClr val="DADCE0"/>
+            </a:solidFill>
+            <a:prstDash val="solid"/>
+          </a:ln>
+        </p:spPr>
+      </p:sp>
+      <p:sp>
+        <p:nvSpPr>
+          <p:cNvPr id="222" name="Text 200"/>
+          <p:cNvSpPr/>
+          <p:nvPr/>
+        </p:nvSpPr>
+        <p:spPr>
+          <a:xfrm>
+            <a:off x="1775765" y="4611319"/>
+            <a:ext cx="650138" cy="128016"/>
+          </a:xfrm>
+          <a:prstGeom prst="rect">
+            <a:avLst/>
+          </a:prstGeom>
+          <a:noFill/>
+          <a:ln/>
+        </p:spPr>
+        <p:txBody>
+          <a:bodyPr wrap="square" lIns="0" tIns="0" rIns="0" bIns="0" rtlCol="0" anchor="ctr">
+            <a:normAutofit/>
+          </a:bodyPr>
+          <a:lstStyle/>
+          <a:p>
+            <a:pPr algn="ctr" indent="0" marL="0">
+              <a:lnSpc>
+                <a:spcPct val="86000"/>
+              </a:lnSpc>
+              <a:buNone/>
+            </a:pPr>
+            <a:r>
+              <a:rPr lang="en-US" sz="480" b="1" dirty="0">
+                <a:solidFill>
+                  <a:srgbClr val="202124"/>
+                </a:solidFill>
+                <a:latin typeface="Arial" pitchFamily="34" charset="0"/>
+                <a:ea typeface="Arial" pitchFamily="34" charset="-122"/>
+                <a:cs typeface="Arial" pitchFamily="34" charset="-120"/>
+              </a:rPr>
+              <a:t>Sanitize request</a:t>
+            </a:r>
+            <a:endParaRPr lang="en-US" sz="480" dirty="0"/>
+          </a:p>
+        </p:txBody>
+      </p:sp>
+      <p:sp>
+        <p:nvSpPr>
+          <p:cNvPr id="223" name="Shape 201"/>
+          <p:cNvSpPr/>
+          <p:nvPr/>
+        </p:nvSpPr>
+        <p:spPr>
+          <a:xfrm>
+            <a:off x="1757477" y="4810658"/>
+            <a:ext cx="686714" cy="146304"/>
+          </a:xfrm>
+          <a:prstGeom prst="roundRect">
+            <a:avLst>
+              <a:gd name="adj" fmla="val 31250"/>
+            </a:avLst>
+          </a:prstGeom>
+          <a:solidFill>
+            <a:srgbClr val="FFFFFF"/>
+          </a:solidFill>
+          <a:ln w="5715">
+            <a:solidFill>
+              <a:srgbClr val="DADCE0"/>
+            </a:solidFill>
+            <a:prstDash val="solid"/>
+          </a:ln>
+        </p:spPr>
+      </p:sp>
+      <p:sp>
+        <p:nvSpPr>
+          <p:cNvPr id="224" name="Text 202"/>
+          <p:cNvSpPr/>
+          <p:nvPr/>
+        </p:nvSpPr>
+        <p:spPr>
+          <a:xfrm>
+            <a:off x="1775765" y="4819802"/>
+            <a:ext cx="650138" cy="128016"/>
+          </a:xfrm>
+          <a:prstGeom prst="rect">
+            <a:avLst/>
+          </a:prstGeom>
+          <a:noFill/>
+          <a:ln/>
+        </p:spPr>
+        <p:txBody>
+          <a:bodyPr wrap="square" lIns="0" tIns="0" rIns="0" bIns="0" rtlCol="0" anchor="ctr">
+            <a:normAutofit/>
+          </a:bodyPr>
+          <a:lstStyle/>
+          <a:p>
+            <a:pPr algn="ctr" indent="0" marL="0">
+              <a:lnSpc>
+                <a:spcPct val="86000"/>
+              </a:lnSpc>
+              <a:buNone/>
+            </a:pPr>
+            <a:r>
+              <a:rPr lang="en-US" sz="480" b="1" dirty="0">
+                <a:solidFill>
+                  <a:srgbClr val="202124"/>
+                </a:solidFill>
+                <a:latin typeface="Arial" pitchFamily="34" charset="0"/>
+                <a:ea typeface="Arial" pitchFamily="34" charset="-122"/>
+                <a:cs typeface="Arial" pitchFamily="34" charset="-120"/>
+              </a:rPr>
+              <a:t>Sanitize response</a:t>
+            </a:r>
+            <a:endParaRPr lang="en-US" sz="480" dirty="0"/>
+          </a:p>
+        </p:txBody>
+      </p:sp>
+      <p:sp>
+        <p:nvSpPr>
+          <p:cNvPr id="225" name="Shape 203"/>
+          <p:cNvSpPr/>
+          <p:nvPr/>
+        </p:nvSpPr>
+        <p:spPr>
+          <a:xfrm>
+            <a:off x="2427732" y="2079346"/>
+            <a:ext cx="512064" cy="210312"/>
+          </a:xfrm>
+          <a:prstGeom prst="roundRect">
+            <a:avLst>
+              <a:gd name="adj" fmla="val 21739"/>
+            </a:avLst>
+          </a:prstGeom>
+          <a:solidFill>
+            <a:srgbClr val="FFFFFF"/>
+          </a:solidFill>
+          <a:ln w="5715">
+            <a:solidFill>
+              <a:srgbClr val="DADCE0"/>
+            </a:solidFill>
+            <a:prstDash val="solid"/>
+          </a:ln>
+        </p:spPr>
+      </p:sp>
+      <p:sp>
+        <p:nvSpPr>
+          <p:cNvPr id="226" name="Text 204"/>
+          <p:cNvSpPr/>
+          <p:nvPr/>
+        </p:nvSpPr>
+        <p:spPr>
+          <a:xfrm>
+            <a:off x="2446020" y="2088490"/>
+            <a:ext cx="475488" cy="192024"/>
+          </a:xfrm>
+          <a:prstGeom prst="rect">
+            <a:avLst/>
+          </a:prstGeom>
+          <a:noFill/>
+          <a:ln/>
+        </p:spPr>
+        <p:txBody>
+          <a:bodyPr wrap="square" lIns="0" tIns="0" rIns="0" bIns="0" rtlCol="0" anchor="ctr">
+            <a:normAutofit/>
+          </a:bodyPr>
+          <a:lstStyle/>
+          <a:p>
+            <a:pPr algn="ctr" indent="0" marL="0">
+              <a:lnSpc>
+                <a:spcPct val="86000"/>
+              </a:lnSpc>
+              <a:buNone/>
+            </a:pPr>
+            <a:r>
+              <a:rPr lang="en-US" sz="480" b="1" dirty="0">
+                <a:solidFill>
+                  <a:srgbClr val="202124"/>
+                </a:solidFill>
+                <a:latin typeface="Arial" pitchFamily="34" charset="0"/>
+                <a:ea typeface="Arial" pitchFamily="34" charset="-122"/>
+                <a:cs typeface="Arial" pitchFamily="34" charset="-120"/>
+              </a:rPr>
+              <a:t>Header &amp; WAF</a:t>
+            </a:r>
+            <a:endParaRPr lang="en-US" sz="480" dirty="0"/>
+          </a:p>
+          <a:p>
+            <a:pPr algn="ctr" indent="0" marL="0">
+              <a:lnSpc>
+                <a:spcPct val="86000"/>
+              </a:lnSpc>
+              <a:buNone/>
+            </a:pPr>
+            <a:r>
+              <a:rPr lang="en-US" sz="420" dirty="0">
+                <a:solidFill>
+                  <a:srgbClr val="202124"/>
+                </a:solidFill>
+                <a:latin typeface="Arial" pitchFamily="34" charset="0"/>
+                <a:ea typeface="Arial" pitchFamily="34" charset="-122"/>
+                <a:cs typeface="Arial" pitchFamily="34" charset="-120"/>
+              </a:rPr>
+              <a:t>policies</a:t>
+            </a:r>
+            <a:endParaRPr lang="en-US" sz="480" dirty="0"/>
+          </a:p>
+        </p:txBody>
+      </p:sp>
+      <p:sp>
+        <p:nvSpPr>
+          <p:cNvPr id="227" name="Shape 205"/>
+          <p:cNvSpPr/>
+          <p:nvPr/>
+        </p:nvSpPr>
+        <p:spPr>
+          <a:xfrm>
+            <a:off x="2427732" y="2606040"/>
+            <a:ext cx="512064" cy="210312"/>
+          </a:xfrm>
+          <a:prstGeom prst="roundRect">
+            <a:avLst>
+              <a:gd name="adj" fmla="val 21739"/>
+            </a:avLst>
+          </a:prstGeom>
+          <a:solidFill>
+            <a:srgbClr val="FFFFFF"/>
+          </a:solidFill>
+          <a:ln w="5715">
+            <a:solidFill>
+              <a:srgbClr val="DADCE0"/>
+            </a:solidFill>
+            <a:prstDash val="solid"/>
+          </a:ln>
+        </p:spPr>
+      </p:sp>
+      <p:sp>
+        <p:nvSpPr>
+          <p:cNvPr id="228" name="Text 206"/>
+          <p:cNvSpPr/>
+          <p:nvPr/>
+        </p:nvSpPr>
+        <p:spPr>
+          <a:xfrm>
+            <a:off x="2446020" y="2615184"/>
+            <a:ext cx="475488" cy="192024"/>
+          </a:xfrm>
+          <a:prstGeom prst="rect">
+            <a:avLst/>
+          </a:prstGeom>
+          <a:noFill/>
+          <a:ln/>
+        </p:spPr>
+        <p:txBody>
+          <a:bodyPr wrap="square" lIns="0" tIns="0" rIns="0" bIns="0" rtlCol="0" anchor="ctr">
+            <a:normAutofit/>
+          </a:bodyPr>
+          <a:lstStyle/>
+          <a:p>
+            <a:pPr algn="ctr" indent="0" marL="0">
+              <a:lnSpc>
+                <a:spcPct val="86000"/>
+              </a:lnSpc>
+              <a:buNone/>
+            </a:pPr>
+            <a:r>
+              <a:rPr lang="en-US" sz="480" b="1" dirty="0">
+                <a:solidFill>
+                  <a:srgbClr val="202124"/>
+                </a:solidFill>
+                <a:latin typeface="Arial" pitchFamily="34" charset="0"/>
+                <a:ea typeface="Arial" pitchFamily="34" charset="-122"/>
+                <a:cs typeface="Arial" pitchFamily="34" charset="-120"/>
+              </a:rPr>
+              <a:t>Sanitize</a:t>
+            </a:r>
+            <a:endParaRPr lang="en-US" sz="480" dirty="0"/>
+          </a:p>
+          <a:p>
+            <a:pPr algn="ctr" indent="0" marL="0">
+              <a:lnSpc>
+                <a:spcPct val="86000"/>
+              </a:lnSpc>
+              <a:buNone/>
+            </a:pPr>
+            <a:r>
+              <a:rPr lang="en-US" sz="420" dirty="0">
+                <a:solidFill>
+                  <a:srgbClr val="202124"/>
+                </a:solidFill>
+                <a:latin typeface="Arial" pitchFamily="34" charset="0"/>
+                <a:ea typeface="Arial" pitchFamily="34" charset="-122"/>
+                <a:cs typeface="Arial" pitchFamily="34" charset="-120"/>
+              </a:rPr>
+              <a:t>prompt</a:t>
+            </a:r>
+            <a:endParaRPr lang="en-US" sz="480" dirty="0"/>
+          </a:p>
+        </p:txBody>
+      </p:sp>
+      <p:sp>
+        <p:nvSpPr>
+          <p:cNvPr id="229" name="Shape 207"/>
+          <p:cNvSpPr/>
+          <p:nvPr/>
+        </p:nvSpPr>
+        <p:spPr>
+          <a:xfrm>
+            <a:off x="3853282" y="1141171"/>
+            <a:ext cx="512064" cy="146304"/>
+          </a:xfrm>
+          <a:prstGeom prst="roundRect">
+            <a:avLst>
+              <a:gd name="adj" fmla="val 31250"/>
+            </a:avLst>
+          </a:prstGeom>
+          <a:solidFill>
+            <a:srgbClr val="FFFFFF"/>
+          </a:solidFill>
+          <a:ln w="5715">
+            <a:solidFill>
+              <a:srgbClr val="DADCE0"/>
+            </a:solidFill>
+            <a:prstDash val="solid"/>
+          </a:ln>
+        </p:spPr>
+      </p:sp>
+      <p:sp>
+        <p:nvSpPr>
+          <p:cNvPr id="230" name="Text 208"/>
+          <p:cNvSpPr/>
+          <p:nvPr/>
+        </p:nvSpPr>
+        <p:spPr>
+          <a:xfrm>
+            <a:off x="3871570" y="1150315"/>
+            <a:ext cx="475488" cy="128016"/>
+          </a:xfrm>
+          <a:prstGeom prst="rect">
+            <a:avLst/>
+          </a:prstGeom>
+          <a:noFill/>
+          <a:ln/>
+        </p:spPr>
+        <p:txBody>
+          <a:bodyPr wrap="square" lIns="0" tIns="0" rIns="0" bIns="0" rtlCol="0" anchor="ctr">
+            <a:normAutofit/>
+          </a:bodyPr>
+          <a:lstStyle/>
+          <a:p>
+            <a:pPr algn="ctr" indent="0" marL="0">
+              <a:lnSpc>
+                <a:spcPct val="86000"/>
+              </a:lnSpc>
+              <a:buNone/>
+            </a:pPr>
+            <a:r>
+              <a:rPr lang="en-US" sz="480" b="1" dirty="0">
+                <a:solidFill>
+                  <a:srgbClr val="202124"/>
+                </a:solidFill>
+                <a:latin typeface="Arial" pitchFamily="34" charset="0"/>
+                <a:ea typeface="Arial" pitchFamily="34" charset="-122"/>
+                <a:cs typeface="Arial" pitchFamily="34" charset="-120"/>
+              </a:rPr>
+              <a:t>Response</a:t>
+            </a:r>
+            <a:endParaRPr lang="en-US" sz="480" dirty="0"/>
+          </a:p>
+        </p:txBody>
+      </p:sp>
+      <p:sp>
+        <p:nvSpPr>
+          <p:cNvPr id="231" name="Shape 209"/>
+          <p:cNvSpPr/>
+          <p:nvPr/>
+        </p:nvSpPr>
+        <p:spPr>
+          <a:xfrm>
+            <a:off x="3853282" y="2719426"/>
+            <a:ext cx="512064" cy="146304"/>
+          </a:xfrm>
+          <a:prstGeom prst="roundRect">
+            <a:avLst>
+              <a:gd name="adj" fmla="val 31250"/>
+            </a:avLst>
+          </a:prstGeom>
+          <a:solidFill>
+            <a:srgbClr val="FFFFFF"/>
+          </a:solidFill>
+          <a:ln w="5715">
+            <a:solidFill>
+              <a:srgbClr val="DADCE0"/>
+            </a:solidFill>
+            <a:prstDash val="solid"/>
+          </a:ln>
+        </p:spPr>
+      </p:sp>
+      <p:sp>
+        <p:nvSpPr>
+          <p:cNvPr id="232" name="Text 210"/>
+          <p:cNvSpPr/>
+          <p:nvPr/>
+        </p:nvSpPr>
+        <p:spPr>
+          <a:xfrm>
+            <a:off x="3871570" y="2728570"/>
+            <a:ext cx="475488" cy="128016"/>
+          </a:xfrm>
+          <a:prstGeom prst="rect">
+            <a:avLst/>
+          </a:prstGeom>
+          <a:noFill/>
+          <a:ln/>
+        </p:spPr>
+        <p:txBody>
+          <a:bodyPr wrap="square" lIns="0" tIns="0" rIns="0" bIns="0" rtlCol="0" anchor="ctr">
+            <a:normAutofit/>
+          </a:bodyPr>
+          <a:lstStyle/>
+          <a:p>
+            <a:pPr algn="ctr" indent="0" marL="0">
+              <a:lnSpc>
+                <a:spcPct val="86000"/>
+              </a:lnSpc>
+              <a:buNone/>
+            </a:pPr>
+            <a:r>
+              <a:rPr lang="en-US" sz="480" b="1" dirty="0">
+                <a:solidFill>
+                  <a:srgbClr val="202124"/>
+                </a:solidFill>
+                <a:latin typeface="Arial" pitchFamily="34" charset="0"/>
+                <a:ea typeface="Arial" pitchFamily="34" charset="-122"/>
+                <a:cs typeface="Arial" pitchFamily="34" charset="-120"/>
+              </a:rPr>
+              <a:t>Response</a:t>
+            </a:r>
+            <a:endParaRPr lang="en-US" sz="480" dirty="0"/>
+          </a:p>
+        </p:txBody>
+      </p:sp>
+      <p:sp>
+        <p:nvSpPr>
+          <p:cNvPr id="233" name="Shape 211"/>
+          <p:cNvSpPr/>
+          <p:nvPr/>
+        </p:nvSpPr>
+        <p:spPr>
+          <a:xfrm>
+            <a:off x="3032150" y="1141171"/>
+            <a:ext cx="512064" cy="146304"/>
+          </a:xfrm>
+          <a:prstGeom prst="roundRect">
+            <a:avLst>
+              <a:gd name="adj" fmla="val 31250"/>
+            </a:avLst>
+          </a:prstGeom>
+          <a:solidFill>
+            <a:srgbClr val="FFFFFF"/>
+          </a:solidFill>
+          <a:ln w="5715">
+            <a:solidFill>
+              <a:srgbClr val="DADCE0"/>
+            </a:solidFill>
+            <a:prstDash val="solid"/>
+          </a:ln>
+        </p:spPr>
+      </p:sp>
+      <p:sp>
+        <p:nvSpPr>
+          <p:cNvPr id="234" name="Text 212"/>
+          <p:cNvSpPr/>
+          <p:nvPr/>
+        </p:nvSpPr>
+        <p:spPr>
+          <a:xfrm>
+            <a:off x="3050438" y="1150315"/>
+            <a:ext cx="475488" cy="128016"/>
+          </a:xfrm>
+          <a:prstGeom prst="rect">
+            <a:avLst/>
+          </a:prstGeom>
+          <a:noFill/>
+          <a:ln/>
+        </p:spPr>
+        <p:txBody>
+          <a:bodyPr wrap="square" lIns="0" tIns="0" rIns="0" bIns="0" rtlCol="0" anchor="ctr">
+            <a:normAutofit/>
+          </a:bodyPr>
+          <a:lstStyle/>
+          <a:p>
+            <a:pPr algn="ctr" indent="0" marL="0">
+              <a:lnSpc>
+                <a:spcPct val="86000"/>
+              </a:lnSpc>
+              <a:buNone/>
+            </a:pPr>
+            <a:r>
+              <a:rPr lang="en-US" sz="480" b="1" dirty="0">
+                <a:solidFill>
+                  <a:srgbClr val="202124"/>
+                </a:solidFill>
+                <a:latin typeface="Arial" pitchFamily="34" charset="0"/>
+                <a:ea typeface="Arial" pitchFamily="34" charset="-122"/>
+                <a:cs typeface="Arial" pitchFamily="34" charset="-120"/>
+              </a:rPr>
+              <a:t>Request</a:t>
+            </a:r>
+            <a:endParaRPr lang="en-US" sz="480" dirty="0"/>
+          </a:p>
+        </p:txBody>
+      </p:sp>
+      <p:sp>
+        <p:nvSpPr>
+          <p:cNvPr id="235" name="Shape 213"/>
+          <p:cNvSpPr/>
+          <p:nvPr/>
+        </p:nvSpPr>
+        <p:spPr>
+          <a:xfrm>
+            <a:off x="3032150" y="2645359"/>
+            <a:ext cx="512064" cy="146304"/>
+          </a:xfrm>
+          <a:prstGeom prst="roundRect">
+            <a:avLst>
+              <a:gd name="adj" fmla="val 31250"/>
+            </a:avLst>
+          </a:prstGeom>
+          <a:solidFill>
+            <a:srgbClr val="FFFFFF"/>
+          </a:solidFill>
+          <a:ln w="5715">
+            <a:solidFill>
+              <a:srgbClr val="DADCE0"/>
+            </a:solidFill>
+            <a:prstDash val="solid"/>
+          </a:ln>
+        </p:spPr>
+      </p:sp>
+      <p:sp>
+        <p:nvSpPr>
+          <p:cNvPr id="236" name="Text 214"/>
+          <p:cNvSpPr/>
+          <p:nvPr/>
+        </p:nvSpPr>
+        <p:spPr>
+          <a:xfrm>
+            <a:off x="3050438" y="2654503"/>
+            <a:ext cx="475488" cy="128016"/>
+          </a:xfrm>
+          <a:prstGeom prst="rect">
+            <a:avLst/>
+          </a:prstGeom>
+          <a:noFill/>
+          <a:ln/>
+        </p:spPr>
+        <p:txBody>
+          <a:bodyPr wrap="square" lIns="0" tIns="0" rIns="0" bIns="0" rtlCol="0" anchor="ctr">
+            <a:normAutofit/>
+          </a:bodyPr>
+          <a:lstStyle/>
+          <a:p>
+            <a:pPr algn="ctr" indent="0" marL="0">
+              <a:lnSpc>
+                <a:spcPct val="86000"/>
+              </a:lnSpc>
+              <a:buNone/>
+            </a:pPr>
+            <a:r>
+              <a:rPr lang="en-US" sz="480" b="1" dirty="0">
+                <a:solidFill>
+                  <a:srgbClr val="202124"/>
+                </a:solidFill>
+                <a:latin typeface="Arial" pitchFamily="34" charset="0"/>
+                <a:ea typeface="Arial" pitchFamily="34" charset="-122"/>
+                <a:cs typeface="Arial" pitchFamily="34" charset="-120"/>
+              </a:rPr>
+              <a:t>Request</a:t>
+            </a:r>
+            <a:endParaRPr lang="en-US" sz="480" dirty="0"/>
+          </a:p>
+        </p:txBody>
+      </p:sp>
+      <p:sp>
+        <p:nvSpPr>
+          <p:cNvPr id="237" name="Text 215"/>
           <p:cNvSpPr/>
           <p:nvPr/>
         </p:nvSpPr>
@@ -29888,7 +30355,7 @@
                 <a:ea typeface="Courier New" pitchFamily="34" charset="-122"/>
                 <a:cs typeface="Courier New" pitchFamily="34" charset="-120"/>
               </a:rPr>
-              <a:t>"Authorization": "Bearer..."</a:t>
+              <a:t>"Authorization": "Bearer &lt;jwt&gt;"</a:t>
             </a:r>
             <a:endParaRPr lang="en-US" sz="1040" dirty="0"/>
           </a:p>
@@ -30945,7 +31412,7 @@
                 <a:ea typeface="Courier New" pitchFamily="34" charset="-122"/>
                 <a:cs typeface="Courier New" pitchFamily="34" charset="-120"/>
               </a:rPr>
-              <a:t>"dpop_jkt": "sha256:9f86d0...",</a:t>
+              <a:t>"dpop_jkt": "sha256:9f86d081",</a:t>
             </a:r>
             <a:endParaRPr lang="en-US" sz="960" dirty="0"/>
           </a:p>
@@ -32676,8 +33143,8 @@
         </p:nvSpPr>
         <p:spPr>
           <a:xfrm>
-            <a:off x="1426464" y="1664208"/>
-            <a:ext cx="1536192" cy="402336"/>
+            <a:off x="1426464" y="1627632"/>
+            <a:ext cx="1536192" cy="384048"/>
           </a:xfrm>
           <a:prstGeom prst="rect">
             <a:avLst/>
@@ -32693,7 +33160,7 @@
               <a:buNone/>
             </a:pPr>
             <a:r>
-              <a:rPr lang="en-US" sz="820" b="1" dirty="0">
+              <a:rPr lang="en-US" sz="800" b="1" dirty="0">
                 <a:solidFill>
                   <a:srgbClr val="3C4043"/>
                 </a:solidFill>
@@ -32703,14 +33170,14 @@
               </a:rPr>
               <a:t>Caller sends OIDC</a:t>
             </a:r>
-            <a:endParaRPr lang="en-US" sz="820" dirty="0"/>
+            <a:endParaRPr lang="en-US" sz="800" dirty="0"/>
           </a:p>
           <a:p>
             <a:pPr indent="0" marL="0">
               <a:buNone/>
             </a:pPr>
             <a:r>
-              <a:rPr lang="en-US" sz="820" b="1" dirty="0">
+              <a:rPr lang="en-US" sz="800" b="1" dirty="0">
                 <a:solidFill>
                   <a:srgbClr val="3C4043"/>
                 </a:solidFill>
@@ -32720,7 +33187,7 @@
               </a:rPr>
               <a:t>JWT + DPoP proof</a:t>
             </a:r>
-            <a:endParaRPr lang="en-US" sz="820" dirty="0"/>
+            <a:endParaRPr lang="en-US" sz="800" dirty="0"/>
           </a:p>
         </p:txBody>
       </p:sp>
@@ -32757,7 +33224,7 @@
         <p:spPr>
           <a:xfrm>
             <a:off x="1261872" y="2048256"/>
-            <a:ext cx="1499616" cy="182880"/>
+            <a:ext cx="1499616" cy="164592"/>
           </a:xfrm>
           <a:prstGeom prst="rect">
             <a:avLst/>
@@ -32773,7 +33240,7 @@
               <a:buNone/>
             </a:pPr>
             <a:r>
-              <a:rPr lang="en-US" sz="800" b="1" dirty="0">
+              <a:rPr lang="en-US" sz="780" b="1" dirty="0">
                 <a:solidFill>
                   <a:srgbClr val="0F2942"/>
                 </a:solidFill>
@@ -32783,7 +33250,7 @@
               </a:rPr>
               <a:t>HTTPS + DPoP JWT</a:t>
             </a:r>
-            <a:endParaRPr lang="en-US" sz="800" dirty="0"/>
+            <a:endParaRPr lang="en-US" sz="780" dirty="0"/>
           </a:p>
         </p:txBody>
       </p:sp>
@@ -32795,7 +33262,7 @@
         </p:nvSpPr>
         <p:spPr>
           <a:xfrm>
-            <a:off x="3182112" y="2304288"/>
+            <a:off x="3182112" y="2267712"/>
             <a:ext cx="292608" cy="292608"/>
           </a:xfrm>
           <a:prstGeom prst="ellipse">
@@ -32815,7 +33282,7 @@
         </p:nvSpPr>
         <p:spPr>
           <a:xfrm>
-            <a:off x="3182112" y="2304288"/>
+            <a:off x="3182112" y="2267712"/>
             <a:ext cx="292608" cy="292608"/>
           </a:xfrm>
           <a:prstGeom prst="rect">
@@ -32854,8 +33321,8 @@
         </p:nvSpPr>
         <p:spPr>
           <a:xfrm>
-            <a:off x="3529584" y="2267712"/>
-            <a:ext cx="1536192" cy="438912"/>
+            <a:off x="3529584" y="2231136"/>
+            <a:ext cx="1536192" cy="402336"/>
           </a:xfrm>
           <a:prstGeom prst="rect">
             <a:avLst/>
@@ -32871,7 +33338,7 @@
               <a:buNone/>
             </a:pPr>
             <a:r>
-              <a:rPr lang="en-US" sz="800" b="1" dirty="0">
+              <a:rPr lang="en-US" sz="780" b="1" dirty="0">
                 <a:solidFill>
                   <a:srgbClr val="3C4043"/>
                 </a:solidFill>
@@ -32881,14 +33348,14 @@
               </a:rPr>
               <a:t>Hop 1 strips spoofed</a:t>
             </a:r>
-            <a:endParaRPr lang="en-US" sz="800" dirty="0"/>
+            <a:endParaRPr lang="en-US" sz="780" dirty="0"/>
           </a:p>
           <a:p>
             <a:pPr indent="0" marL="0">
               <a:buNone/>
             </a:pPr>
             <a:r>
-              <a:rPr lang="en-US" sz="800" b="1" dirty="0">
+              <a:rPr lang="en-US" sz="780" b="1" dirty="0">
                 <a:solidFill>
                   <a:srgbClr val="3C4043"/>
                 </a:solidFill>
@@ -32898,14 +33365,14 @@
               </a:rPr>
               <a:t>headers &amp; mints OBO</a:t>
             </a:r>
-            <a:endParaRPr lang="en-US" sz="800" dirty="0"/>
+            <a:endParaRPr lang="en-US" sz="780" dirty="0"/>
           </a:p>
           <a:p>
             <a:pPr indent="0" marL="0">
               <a:buNone/>
             </a:pPr>
             <a:r>
-              <a:rPr lang="en-US" sz="800" b="1" dirty="0">
+              <a:rPr lang="en-US" sz="780" b="1" dirty="0">
                 <a:solidFill>
                   <a:srgbClr val="3C4043"/>
                 </a:solidFill>
@@ -32915,7 +33382,7 @@
               </a:rPr>
               <a:t>TenantContext</a:t>
             </a:r>
-            <a:endParaRPr lang="en-US" sz="800" dirty="0"/>
+            <a:endParaRPr lang="en-US" sz="780" dirty="0"/>
           </a:p>
         </p:txBody>
       </p:sp>
@@ -32927,7 +33394,7 @@
         </p:nvSpPr>
         <p:spPr>
           <a:xfrm>
-            <a:off x="3136392" y="2889504"/>
+            <a:off x="3136392" y="2907792"/>
             <a:ext cx="1956816" cy="0"/>
           </a:xfrm>
           <a:prstGeom prst="line">
@@ -32951,24 +33418,26 @@
         </p:nvSpPr>
         <p:spPr>
           <a:xfrm>
-            <a:off x="3200400" y="2688336"/>
-            <a:ext cx="1828800" cy="182880"/>
-          </a:xfrm>
-          <a:prstGeom prst="rect">
-            <a:avLst/>
-          </a:prstGeom>
-          <a:noFill/>
-          <a:ln/>
-        </p:spPr>
-        <p:txBody>
-          <a:bodyPr wrap="square" rtlCol="0" anchor="ctr"/>
+            <a:off x="3163824" y="2697480"/>
+            <a:ext cx="1901952" cy="173736"/>
+          </a:xfrm>
+          <a:prstGeom prst="rect">
+            <a:avLst/>
+          </a:prstGeom>
+          <a:noFill/>
+          <a:ln/>
+        </p:spPr>
+        <p:txBody>
+          <a:bodyPr wrap="square" rtlCol="0" anchor="ctr">
+            <a:normAutofit/>
+          </a:bodyPr>
           <a:lstStyle/>
           <a:p>
             <a:pPr algn="ctr" indent="0" marL="0">
               <a:buNone/>
             </a:pPr>
             <a:r>
-              <a:rPr lang="en-US" sz="760" b="1" dirty="0">
+              <a:rPr lang="en-US" sz="700" b="1" dirty="0">
                 <a:solidFill>
                   <a:srgbClr val="0D7A75"/>
                 </a:solidFill>
@@ -32978,7 +33447,7 @@
               </a:rPr>
               <a:t>Verify OBO + DPoP → Mint Sealed TenantContext</a:t>
             </a:r>
-            <a:endParaRPr lang="en-US" sz="760" dirty="0"/>
+            <a:endParaRPr lang="en-US" sz="700" dirty="0"/>
           </a:p>
         </p:txBody>
       </p:sp>
@@ -32990,7 +33459,7 @@
         </p:nvSpPr>
         <p:spPr>
           <a:xfrm>
-            <a:off x="5285232" y="2944368"/>
+            <a:off x="5285232" y="2926080"/>
             <a:ext cx="292608" cy="292608"/>
           </a:xfrm>
           <a:prstGeom prst="ellipse">
@@ -33010,7 +33479,7 @@
         </p:nvSpPr>
         <p:spPr>
           <a:xfrm>
-            <a:off x="5285232" y="2944368"/>
+            <a:off x="5285232" y="2926080"/>
             <a:ext cx="292608" cy="292608"/>
           </a:xfrm>
           <a:prstGeom prst="rect">
@@ -33049,8 +33518,8 @@
         </p:nvSpPr>
         <p:spPr>
           <a:xfrm>
-            <a:off x="5632704" y="2907792"/>
-            <a:ext cx="1536192" cy="438912"/>
+            <a:off x="5632704" y="2889504"/>
+            <a:ext cx="1536192" cy="402336"/>
           </a:xfrm>
           <a:prstGeom prst="rect">
             <a:avLst/>
@@ -33066,7 +33535,7 @@
               <a:buNone/>
             </a:pPr>
             <a:r>
-              <a:rPr lang="en-US" sz="800" b="1" dirty="0">
+              <a:rPr lang="en-US" sz="780" b="1" dirty="0">
                 <a:solidFill>
                   <a:srgbClr val="3C4043"/>
                 </a:solidFill>
@@ -33076,14 +33545,14 @@
               </a:rPr>
               <a:t>Hops 2–3 filter ARD</a:t>
             </a:r>
-            <a:endParaRPr lang="en-US" sz="800" dirty="0"/>
+            <a:endParaRPr lang="en-US" sz="780" dirty="0"/>
           </a:p>
           <a:p>
             <a:pPr indent="0" marL="0">
               <a:buNone/>
             </a:pPr>
             <a:r>
-              <a:rPr lang="en-US" sz="800" b="1" dirty="0">
+              <a:rPr lang="en-US" sz="780" b="1" dirty="0">
                 <a:solidFill>
                   <a:srgbClr val="3C4043"/>
                 </a:solidFill>
@@ -33093,14 +33562,14 @@
               </a:rPr>
               <a:t>catalog &amp; scope L1–L5</a:t>
             </a:r>
-            <a:endParaRPr lang="en-US" sz="800" dirty="0"/>
+            <a:endParaRPr lang="en-US" sz="780" dirty="0"/>
           </a:p>
           <a:p>
             <a:pPr indent="0" marL="0">
               <a:buNone/>
             </a:pPr>
             <a:r>
-              <a:rPr lang="en-US" sz="800" b="1" dirty="0">
+              <a:rPr lang="en-US" sz="780" b="1" dirty="0">
                 <a:solidFill>
                   <a:srgbClr val="3C4043"/>
                 </a:solidFill>
@@ -33110,7 +33579,7 @@
               </a:rPr>
               <a:t>memory namespace</a:t>
             </a:r>
-            <a:endParaRPr lang="en-US" sz="800" dirty="0"/>
+            <a:endParaRPr lang="en-US" sz="780" dirty="0"/>
           </a:p>
         </p:txBody>
       </p:sp>
@@ -33146,24 +33615,26 @@
         </p:nvSpPr>
         <p:spPr>
           <a:xfrm>
-            <a:off x="5303520" y="3346704"/>
-            <a:ext cx="1828800" cy="182880"/>
-          </a:xfrm>
-          <a:prstGeom prst="rect">
-            <a:avLst/>
-          </a:prstGeom>
-          <a:noFill/>
-          <a:ln/>
-        </p:spPr>
-        <p:txBody>
-          <a:bodyPr wrap="square" rtlCol="0" anchor="ctr"/>
+            <a:off x="5266944" y="3337560"/>
+            <a:ext cx="1901952" cy="173736"/>
+          </a:xfrm>
+          <a:prstGeom prst="rect">
+            <a:avLst/>
+          </a:prstGeom>
+          <a:noFill/>
+          <a:ln/>
+        </p:spPr>
+        <p:txBody>
+          <a:bodyPr wrap="square" rtlCol="0" anchor="ctr">
+            <a:normAutofit/>
+          </a:bodyPr>
           <a:lstStyle/>
           <a:p>
             <a:pPr algn="ctr" indent="0" marL="0">
               <a:buNone/>
             </a:pPr>
             <a:r>
-              <a:rPr lang="en-US" sz="760" b="1" dirty="0">
+              <a:rPr lang="en-US" sz="720" b="1" dirty="0">
                 <a:solidFill>
                   <a:srgbClr val="54728C"/>
                 </a:solidFill>
@@ -33171,9 +33642,9 @@
                 <a:ea typeface="Roboto" pitchFamily="34" charset="-122"/>
                 <a:cs typeface="Roboto" pitchFamily="34" charset="-120"/>
               </a:rPr>
-              <a:t>ARD • Scoped Agent • &amp; Memory ACL</a:t>
-            </a:r>
-            <a:endParaRPr lang="en-US" sz="760" dirty="0"/>
+              <a:t>ARD • Scoped Agent &amp; Memory ACL</a:t>
+            </a:r>
+            <a:endParaRPr lang="en-US" sz="720" dirty="0"/>
           </a:p>
         </p:txBody>
       </p:sp>
@@ -34535,8 +35006,8 @@
         </p:nvSpPr>
         <p:spPr>
           <a:xfrm>
-            <a:off x="530352" y="2852928"/>
-            <a:ext cx="1975104" cy="1316736"/>
+            <a:off x="493776" y="2852928"/>
+            <a:ext cx="1956816" cy="1316736"/>
           </a:xfrm>
           <a:prstGeom prst="roundRect">
             <a:avLst>
@@ -34557,8 +35028,8 @@
         </p:nvSpPr>
         <p:spPr>
           <a:xfrm>
-            <a:off x="603504" y="2852928"/>
-            <a:ext cx="1828800" cy="1316736"/>
+            <a:off x="566928" y="2852928"/>
+            <a:ext cx="1810512" cy="1316736"/>
           </a:xfrm>
           <a:prstGeom prst="rect">
             <a:avLst/>
@@ -34613,8 +35084,8 @@
         </p:nvSpPr>
         <p:spPr>
           <a:xfrm>
-            <a:off x="3749040" y="2852928"/>
-            <a:ext cx="1975104" cy="1316736"/>
+            <a:off x="3840480" y="2852928"/>
+            <a:ext cx="1956816" cy="1316736"/>
           </a:xfrm>
           <a:prstGeom prst="roundRect">
             <a:avLst>
@@ -34635,8 +35106,8 @@
         </p:nvSpPr>
         <p:spPr>
           <a:xfrm>
-            <a:off x="3822192" y="2852928"/>
-            <a:ext cx="1828800" cy="1316736"/>
+            <a:off x="3913632" y="2852928"/>
+            <a:ext cx="1810512" cy="1316736"/>
           </a:xfrm>
           <a:prstGeom prst="rect">
             <a:avLst/>
@@ -34692,7 +35163,7 @@
         <p:spPr>
           <a:xfrm>
             <a:off x="6784848" y="2852928"/>
-            <a:ext cx="1975104" cy="1316736"/>
+            <a:ext cx="1956816" cy="1316736"/>
           </a:xfrm>
           <a:prstGeom prst="roundRect">
             <a:avLst>
@@ -34714,7 +35185,7 @@
         <p:spPr>
           <a:xfrm>
             <a:off x="6858000" y="2852928"/>
-            <a:ext cx="1828800" cy="1316736"/>
+            <a:ext cx="1810512" cy="1316736"/>
           </a:xfrm>
           <a:prstGeom prst="rect">
             <a:avLst/>
@@ -34770,7 +35241,7 @@
         <p:spPr>
           <a:xfrm>
             <a:off x="9710928" y="2852928"/>
-            <a:ext cx="1975104" cy="1316736"/>
+            <a:ext cx="1956816" cy="1316736"/>
           </a:xfrm>
           <a:prstGeom prst="roundRect">
             <a:avLst>
@@ -34792,7 +35263,7 @@
         <p:spPr>
           <a:xfrm>
             <a:off x="9784080" y="2852928"/>
-            <a:ext cx="1828800" cy="1316736"/>
+            <a:ext cx="1810512" cy="1316736"/>
           </a:xfrm>
           <a:prstGeom prst="rect">
             <a:avLst/>
@@ -34847,8 +35318,8 @@
         </p:nvSpPr>
         <p:spPr>
           <a:xfrm>
-            <a:off x="2468880" y="1572768"/>
-            <a:ext cx="1316736" cy="1024128"/>
+            <a:off x="2514600" y="1572768"/>
+            <a:ext cx="1261872" cy="1024128"/>
           </a:xfrm>
           <a:prstGeom prst="roundRect">
             <a:avLst>
@@ -34874,8 +35345,8 @@
         </p:nvSpPr>
         <p:spPr>
           <a:xfrm>
-            <a:off x="2505456" y="1627632"/>
-            <a:ext cx="1243584" cy="914400"/>
+            <a:off x="2551176" y="1627632"/>
+            <a:ext cx="1188720" cy="914400"/>
           </a:xfrm>
           <a:prstGeom prst="rect">
             <a:avLst/>
@@ -34891,7 +35362,7 @@
               <a:buNone/>
             </a:pPr>
             <a:r>
-              <a:rPr lang="en-US" sz="880" b="1" dirty="0">
+              <a:rPr lang="en-US" sz="860" b="1" dirty="0">
                 <a:solidFill>
                   <a:srgbClr val="3C4043"/>
                 </a:solidFill>
@@ -34901,14 +35372,14 @@
               </a:rPr>
               <a:t>1. Validates OIDC JWT</a:t>
             </a:r>
-            <a:endParaRPr lang="en-US" sz="880" dirty="0"/>
+            <a:endParaRPr lang="en-US" sz="860" dirty="0"/>
           </a:p>
           <a:p>
             <a:pPr algn="ctr" indent="0" marL="0">
               <a:buNone/>
             </a:pPr>
             <a:r>
-              <a:rPr lang="en-US" sz="880" b="1" dirty="0">
+              <a:rPr lang="en-US" sz="860" b="1" dirty="0">
                 <a:solidFill>
                   <a:srgbClr val="3C4043"/>
                 </a:solidFill>
@@ -34918,7 +35389,7 @@
               </a:rPr>
               <a:t>&amp; RFC 9449 DPoP</a:t>
             </a:r>
-            <a:endParaRPr lang="en-US" sz="880" dirty="0"/>
+            <a:endParaRPr lang="en-US" sz="860" dirty="0"/>
           </a:p>
         </p:txBody>
       </p:sp>
@@ -34930,8 +35401,8 @@
         </p:nvSpPr>
         <p:spPr>
           <a:xfrm>
-            <a:off x="2505456" y="3182112"/>
-            <a:ext cx="1243584" cy="0"/>
+            <a:off x="2450592" y="3182112"/>
+            <a:ext cx="1389888" cy="0"/>
           </a:xfrm>
           <a:prstGeom prst="line">
             <a:avLst/>
@@ -34954,8 +35425,8 @@
         </p:nvSpPr>
         <p:spPr>
           <a:xfrm>
-            <a:off x="2505456" y="3730752"/>
-            <a:ext cx="1243584" cy="0"/>
+            <a:off x="2450592" y="3730752"/>
+            <a:ext cx="1389888" cy="0"/>
           </a:xfrm>
           <a:prstGeom prst="line">
             <a:avLst/>
@@ -34978,8 +35449,8 @@
         </p:nvSpPr>
         <p:spPr>
           <a:xfrm>
-            <a:off x="2432304" y="3877056"/>
-            <a:ext cx="1389888" cy="859536"/>
+            <a:off x="2514600" y="3877056"/>
+            <a:ext cx="1261872" cy="859536"/>
           </a:xfrm>
           <a:prstGeom prst="roundRect">
             <a:avLst>
@@ -35005,8 +35476,8 @@
         </p:nvSpPr>
         <p:spPr>
           <a:xfrm>
-            <a:off x="2487168" y="3913632"/>
-            <a:ext cx="1280160" cy="786384"/>
+            <a:off x="2551176" y="3913632"/>
+            <a:ext cx="1188720" cy="786384"/>
           </a:xfrm>
           <a:prstGeom prst="rect">
             <a:avLst/>
@@ -35022,7 +35493,7 @@
               <a:buNone/>
             </a:pPr>
             <a:r>
-              <a:rPr lang="en-US" sz="820" b="1" dirty="0">
+              <a:rPr lang="en-US" sz="800" b="1" dirty="0">
                 <a:solidFill>
                   <a:srgbClr val="A50E0E"/>
                 </a:solidFill>
@@ -35032,14 +35503,14 @@
               </a:rPr>
               <a:t>2. Rejects spoofed headers</a:t>
             </a:r>
-            <a:endParaRPr lang="en-US" sz="820" dirty="0"/>
+            <a:endParaRPr lang="en-US" sz="800" dirty="0"/>
           </a:p>
           <a:p>
             <a:pPr algn="ctr" indent="0" marL="0">
               <a:buNone/>
             </a:pPr>
             <a:r>
-              <a:rPr lang="en-US" sz="820" b="1" dirty="0">
+              <a:rPr lang="en-US" sz="800" b="1" dirty="0">
                 <a:solidFill>
                   <a:srgbClr val="A50E0E"/>
                 </a:solidFill>
@@ -35049,14 +35520,14 @@
               </a:rPr>
               <a:t>with immediate HTTP</a:t>
             </a:r>
-            <a:endParaRPr lang="en-US" sz="820" dirty="0"/>
+            <a:endParaRPr lang="en-US" sz="800" dirty="0"/>
           </a:p>
           <a:p>
             <a:pPr algn="ctr" indent="0" marL="0">
               <a:buNone/>
             </a:pPr>
             <a:r>
-              <a:rPr lang="en-US" sz="820" b="1" dirty="0">
+              <a:rPr lang="en-US" sz="800" b="1" dirty="0">
                 <a:solidFill>
                   <a:srgbClr val="A50E0E"/>
                 </a:solidFill>
@@ -35066,7 +35537,7 @@
               </a:rPr>
               <a:t>401 / 403 fail-closed</a:t>
             </a:r>
-            <a:endParaRPr lang="en-US" sz="820" dirty="0"/>
+            <a:endParaRPr lang="en-US" sz="800" dirty="0"/>
           </a:p>
         </p:txBody>
       </p:sp>
@@ -38380,7 +38851,9 @@
           <a:ln/>
         </p:spPr>
         <p:txBody>
-          <a:bodyPr wrap="square" rtlCol="0" anchor="ctr"/>
+          <a:bodyPr wrap="square" rtlCol="0" anchor="ctr">
+            <a:normAutofit/>
+          </a:bodyPr>
           <a:lstStyle/>
           <a:p>
             <a:pPr indent="0" marL="0">
@@ -38436,7 +38909,7 @@
                 <a:ea typeface="Roboto" pitchFamily="34" charset="-122"/>
                 <a:cs typeface="Roboto" pitchFamily="34" charset="-120"/>
               </a:rPr>
-              <a:t>Central Ingress Hub project + Shared Pool + Dedicated Enterprise Spoke projects (Single shared GCP project (ramp-portal-dev); logica…</a:t>
+              <a:t>Central Ingress Hub project + Shared Pool + Dedicated Enterprise Spoke projects</a:t>
             </a:r>
             <a:endParaRPr lang="en-US" sz="740" dirty="0"/>
           </a:p>
@@ -38507,7 +38980,9 @@
           <a:ln/>
         </p:spPr>
         <p:txBody>
-          <a:bodyPr wrap="square" rtlCol="0" anchor="ctr"/>
+          <a:bodyPr wrap="square" rtlCol="0" anchor="ctr">
+            <a:normAutofit/>
+          </a:bodyPr>
           <a:lstStyle/>
           <a:p>
             <a:pPr indent="0" marL="0">
@@ -38563,7 +39038,7 @@
                 <a:ea typeface="Roboto" pitchFamily="34" charset="-122"/>
                 <a:cs typeface="Roboto" pitchFamily="34" charset="-120"/>
               </a:rPr>
-              <a:t>Firestore dynamic tier router dispatches Standard -&gt; Pool, Enterprise -&gt; PSC Spoke (Shared Cloud Run v2 &amp; shared Vertex AI Agent Eng…</a:t>
+              <a:t>Firestore dynamic tier router dispatches Standard -&gt; Pool, Enterprise -&gt; PSC Spoke</a:t>
             </a:r>
             <a:endParaRPr lang="en-US" sz="740" dirty="0"/>
           </a:p>
@@ -38634,7 +39109,9 @@
           <a:ln/>
         </p:spPr>
         <p:txBody>
-          <a:bodyPr wrap="square" rtlCol="0" anchor="ctr"/>
+          <a:bodyPr wrap="square" rtlCol="0" anchor="ctr">
+            <a:normAutofit/>
+          </a:bodyPr>
           <a:lstStyle/>
           <a:p>
             <a:pPr indent="0" marL="0">
@@ -38690,7 +39167,7 @@
                 <a:ea typeface="Roboto" pitchFamily="34" charset="-122"/>
                 <a:cs typeface="Roboto" pitchFamily="34" charset="-120"/>
               </a:rPr>
-              <a:t>Unidirectional Private Service Connect (PSC) endpoints (10.10.0.50 -&gt; /24 NAT) (Shared VPC protected by Cloud Armor L7 WAF header sa…</a:t>
+              <a:t>Unidirectional Private Service Connect (PSC) endpoints (10.10.0.50 -&gt; /24 NAT)</a:t>
             </a:r>
             <a:endParaRPr lang="en-US" sz="740" dirty="0"/>
           </a:p>
@@ -38761,7 +39238,9 @@
           <a:ln/>
         </p:spPr>
         <p:txBody>
-          <a:bodyPr wrap="square" rtlCol="0" anchor="ctr"/>
+          <a:bodyPr wrap="square" rtlCol="0" anchor="ctr">
+            <a:normAutofit/>
+          </a:bodyPr>
           <a:lstStyle/>
           <a:p>
             <a:pPr indent="0" marL="0">
@@ -38817,7 +39296,7 @@
                 <a:ea typeface="Roboto" pitchFamily="34" charset="-122"/>
                 <a:cs typeface="Roboto" pitchFamily="34" charset="-120"/>
               </a:rPr>
-              <a:t>Unified Hub OIDC verification + tier-scoped OBO/DPoP token forwarding (IAP OIDC + IAM STS RFC 8693 OBO &amp; RFC 9449 DPoP sender-c)</a:t>
+              <a:t>Unified Hub OIDC verification + tier-scoped OBO/DPoP token forwarding</a:t>
             </a:r>
             <a:endParaRPr lang="en-US" sz="740" dirty="0"/>
           </a:p>

</xml_diff>